<commit_message>
Rebrand both Yangmei grade 11 traffic safety courses and teaching kits
</commit_message>
<xml_diff>
--- a/materials/teacher-slides.pptx
+++ b/materials/teacher-slides.pptx
@@ -2,32 +2,32 @@
 <file path=ppt/presentation.xml><?xml version="1.0" encoding="utf-8"?>
 <p:presentation xmlns:p="http://schemas.openxmlformats.org/presentationml/2006/main">
   <p:sldMasterIdLst>
-    <p:sldMasterId xmlns:r="http://schemas.openxmlformats.org/officeDocument/2006/relationships" id="2147483648" r:id="R5a572ea745464272"/>
+    <p:sldMasterId xmlns:r="http://schemas.openxmlformats.org/officeDocument/2006/relationships" id="2147483648" r:id="Rbbcf045af39540b0"/>
   </p:sldMasterIdLst>
   <p:notesMasterIdLst>
-    <p:notesMasterId xmlns:r="http://schemas.openxmlformats.org/officeDocument/2006/relationships" r:id="R147fa82947234543"/>
+    <p:notesMasterId xmlns:r="http://schemas.openxmlformats.org/officeDocument/2006/relationships" r:id="R5115bc29cd4d416f"/>
   </p:notesMasterIdLst>
   <p:sldIdLst>
-    <p:sldId xmlns:r="http://schemas.openxmlformats.org/officeDocument/2006/relationships" id="256" r:id="Ra139de0aa8954039"/>
-    <p:sldId xmlns:r="http://schemas.openxmlformats.org/officeDocument/2006/relationships" id="257" r:id="R7381e92bd2b84e17"/>
-    <p:sldId xmlns:r="http://schemas.openxmlformats.org/officeDocument/2006/relationships" id="258" r:id="Ra8514f84bc134d1d"/>
-    <p:sldId xmlns:r="http://schemas.openxmlformats.org/officeDocument/2006/relationships" id="259" r:id="Rd33c2e1b76ee48f0"/>
-    <p:sldId xmlns:r="http://schemas.openxmlformats.org/officeDocument/2006/relationships" id="260" r:id="Rbe96ec5b2e444aae"/>
-    <p:sldId xmlns:r="http://schemas.openxmlformats.org/officeDocument/2006/relationships" id="261" r:id="Rc66772aa82554fa2"/>
-    <p:sldId xmlns:r="http://schemas.openxmlformats.org/officeDocument/2006/relationships" id="262" r:id="R3a7fb6f2303f4184"/>
-    <p:sldId xmlns:r="http://schemas.openxmlformats.org/officeDocument/2006/relationships" id="263" r:id="R94181c2d6661475d"/>
-    <p:sldId xmlns:r="http://schemas.openxmlformats.org/officeDocument/2006/relationships" id="264" r:id="R25aab5e0674f42d7"/>
-    <p:sldId xmlns:r="http://schemas.openxmlformats.org/officeDocument/2006/relationships" id="265" r:id="Rdb5c2aea70d44203"/>
-    <p:sldId xmlns:r="http://schemas.openxmlformats.org/officeDocument/2006/relationships" id="266" r:id="Rf579fe8a84d04a99"/>
-    <p:sldId xmlns:r="http://schemas.openxmlformats.org/officeDocument/2006/relationships" id="267" r:id="R640fe6ca315648b7"/>
-    <p:sldId xmlns:r="http://schemas.openxmlformats.org/officeDocument/2006/relationships" id="268" r:id="Ra378282e29234cfa"/>
-    <p:sldId xmlns:r="http://schemas.openxmlformats.org/officeDocument/2006/relationships" id="269" r:id="R7598f57a04bd402d"/>
-    <p:sldId xmlns:r="http://schemas.openxmlformats.org/officeDocument/2006/relationships" id="270" r:id="R8231984abe9d412b"/>
-    <p:sldId xmlns:r="http://schemas.openxmlformats.org/officeDocument/2006/relationships" id="271" r:id="R6aa9dd4b3a544d85"/>
-    <p:sldId xmlns:r="http://schemas.openxmlformats.org/officeDocument/2006/relationships" id="272" r:id="Raf795de670594428"/>
-    <p:sldId xmlns:r="http://schemas.openxmlformats.org/officeDocument/2006/relationships" id="273" r:id="R8769282fbaa64e82"/>
-    <p:sldId xmlns:r="http://schemas.openxmlformats.org/officeDocument/2006/relationships" id="274" r:id="R29d7dd8e14304ba1"/>
-    <p:sldId xmlns:r="http://schemas.openxmlformats.org/officeDocument/2006/relationships" id="275" r:id="Rbac22c0bde7346ba"/>
+    <p:sldId xmlns:r="http://schemas.openxmlformats.org/officeDocument/2006/relationships" id="256" r:id="Rc7272f96adf94786"/>
+    <p:sldId xmlns:r="http://schemas.openxmlformats.org/officeDocument/2006/relationships" id="257" r:id="R2fb490e8177b4470"/>
+    <p:sldId xmlns:r="http://schemas.openxmlformats.org/officeDocument/2006/relationships" id="258" r:id="R39454f06b7414831"/>
+    <p:sldId xmlns:r="http://schemas.openxmlformats.org/officeDocument/2006/relationships" id="259" r:id="R8cdd9b5ce5e84dc4"/>
+    <p:sldId xmlns:r="http://schemas.openxmlformats.org/officeDocument/2006/relationships" id="260" r:id="Rbb6b2749584c442f"/>
+    <p:sldId xmlns:r="http://schemas.openxmlformats.org/officeDocument/2006/relationships" id="261" r:id="Rcc101840489c4346"/>
+    <p:sldId xmlns:r="http://schemas.openxmlformats.org/officeDocument/2006/relationships" id="262" r:id="R0b4b84ac27d04aec"/>
+    <p:sldId xmlns:r="http://schemas.openxmlformats.org/officeDocument/2006/relationships" id="263" r:id="Rc9d5e1014f19401c"/>
+    <p:sldId xmlns:r="http://schemas.openxmlformats.org/officeDocument/2006/relationships" id="264" r:id="Re658eadc5a6942eb"/>
+    <p:sldId xmlns:r="http://schemas.openxmlformats.org/officeDocument/2006/relationships" id="265" r:id="Rf42b980e83b44224"/>
+    <p:sldId xmlns:r="http://schemas.openxmlformats.org/officeDocument/2006/relationships" id="266" r:id="R33c9df94079f4545"/>
+    <p:sldId xmlns:r="http://schemas.openxmlformats.org/officeDocument/2006/relationships" id="267" r:id="Rc120b1bb52e04274"/>
+    <p:sldId xmlns:r="http://schemas.openxmlformats.org/officeDocument/2006/relationships" id="268" r:id="Rccf471e5f91f4476"/>
+    <p:sldId xmlns:r="http://schemas.openxmlformats.org/officeDocument/2006/relationships" id="269" r:id="Re9386a6b2ea74b56"/>
+    <p:sldId xmlns:r="http://schemas.openxmlformats.org/officeDocument/2006/relationships" id="270" r:id="Ra4d7a1cddd684818"/>
+    <p:sldId xmlns:r="http://schemas.openxmlformats.org/officeDocument/2006/relationships" id="271" r:id="Rd7bb500a5a444299"/>
+    <p:sldId xmlns:r="http://schemas.openxmlformats.org/officeDocument/2006/relationships" id="272" r:id="Rf9130cb6649c49d9"/>
+    <p:sldId xmlns:r="http://schemas.openxmlformats.org/officeDocument/2006/relationships" id="273" r:id="R5bb243ca27d84daa"/>
+    <p:sldId xmlns:r="http://schemas.openxmlformats.org/officeDocument/2006/relationships" id="274" r:id="R7298d8e6f9c04f81"/>
+    <p:sldId xmlns:r="http://schemas.openxmlformats.org/officeDocument/2006/relationships" id="275" r:id="R62a80d8214b140e0"/>
   </p:sldIdLst>
   <p:sldSz cx="12192000" cy="6858000"/>
   <p:notesSz cx="6858000" cy="9144000"/>
@@ -1266,7 +1266,7 @@
           <a:lstStyle xmlns:a="http://schemas.openxmlformats.org/drawingml/2006/main"/>
           <a:p xmlns:a="http://schemas.openxmlformats.org/drawingml/2006/main">
             <a:r>
-              <a:t>請兩位學生簡短分享。以學生可做的行動連結駕駛義務與道路設計，不要求揭露個人行蹤。</a:t>
+              <a:t>請兩位學生簡短分享。以「楊光梅好」諧音「陽光美好」連結青春與未來，說明安全第一是守住這一切的前提。以學生可做的行動連結駕駛義務與道路設計，不要求揭露個人行蹤。</a:t>
             </a:r>
           </a:p>
         </p:txBody>
@@ -1933,7 +1933,7 @@
           <p:cNvPr id="3" name="Title">
             <a:extLst xmlns:a="http://schemas.openxmlformats.org/drawingml/2006/main">
               <a:ext uri="{FF2B5EF4-FFF2-40B4-BE49-F238E27FC236}">
-                <a16:creationId xmlns:a16="http://schemas.microsoft.com/office/drawing/2014/main" id="{A45A322A-0B62-476B-AB18-373A9FB72EC8}"/>
+                <a16:creationId xmlns:a16="http://schemas.microsoft.com/office/drawing/2014/main" id="{EC97E708-594F-430E-85E6-C24F2EBDFC40}"/>
               </a:ext>
             </a:extLst>
           </p:cNvPr>
@@ -2090,7 +2090,7 @@
           <p:cNvPr id="2" name="Subtitle">
             <a:extLst xmlns:a="http://schemas.openxmlformats.org/drawingml/2006/main">
               <a:ext uri="{FF2B5EF4-FFF2-40B4-BE49-F238E27FC236}">
-                <a16:creationId xmlns:a16="http://schemas.microsoft.com/office/drawing/2014/main" id="{4A4FE8F6-920B-4C37-8220-E9CAE92B5E1B}"/>
+                <a16:creationId xmlns:a16="http://schemas.microsoft.com/office/drawing/2014/main" id="{8E704E09-B13E-427B-AC95-A60DB69F3C26}"/>
               </a:ext>
             </a:extLst>
           </p:cNvPr>
@@ -2264,7 +2264,7 @@
           <p:cNvPr id="2" name="Section title">
             <a:extLst xmlns:a="http://schemas.openxmlformats.org/drawingml/2006/main">
               <a:ext uri="{FF2B5EF4-FFF2-40B4-BE49-F238E27FC236}">
-                <a16:creationId xmlns:a16="http://schemas.microsoft.com/office/drawing/2014/main" id="{BB633385-6BDE-4E36-A230-DAD3856D1320}"/>
+                <a16:creationId xmlns:a16="http://schemas.microsoft.com/office/drawing/2014/main" id="{AFD43A5E-9900-4711-9A0A-1A0F3C396F70}"/>
               </a:ext>
             </a:extLst>
           </p:cNvPr>
@@ -2438,7 +2438,7 @@
           <p:cNvPr id="3" name="Title">
             <a:extLst xmlns:a="http://schemas.openxmlformats.org/drawingml/2006/main">
               <a:ext uri="{FF2B5EF4-FFF2-40B4-BE49-F238E27FC236}">
-                <a16:creationId xmlns:a16="http://schemas.microsoft.com/office/drawing/2014/main" id="{E2D45AA4-77FF-4AB4-B64D-997C0D6FC675}"/>
+                <a16:creationId xmlns:a16="http://schemas.microsoft.com/office/drawing/2014/main" id="{D5D5D137-5A8E-4A0D-8CAC-2FFF130B7F6E}"/>
               </a:ext>
             </a:extLst>
           </p:cNvPr>
@@ -2595,7 +2595,7 @@
           <p:cNvPr id="2" name="Body">
             <a:extLst xmlns:a="http://schemas.openxmlformats.org/drawingml/2006/main">
               <a:ext uri="{FF2B5EF4-FFF2-40B4-BE49-F238E27FC236}">
-                <a16:creationId xmlns:a16="http://schemas.microsoft.com/office/drawing/2014/main" id="{A025C397-21C9-4C57-A2B0-CB016FDA8218}"/>
+                <a16:creationId xmlns:a16="http://schemas.microsoft.com/office/drawing/2014/main" id="{6BEED116-F5F2-47EE-82DC-EE67893727A5}"/>
               </a:ext>
             </a:extLst>
           </p:cNvPr>
@@ -2769,7 +2769,7 @@
           <p:cNvPr id="4" name="Title">
             <a:extLst xmlns:a="http://schemas.openxmlformats.org/drawingml/2006/main">
               <a:ext uri="{FF2B5EF4-FFF2-40B4-BE49-F238E27FC236}">
-                <a16:creationId xmlns:a16="http://schemas.microsoft.com/office/drawing/2014/main" id="{EDCA43E7-885E-4386-897E-BEFBD408BA0A}"/>
+                <a16:creationId xmlns:a16="http://schemas.microsoft.com/office/drawing/2014/main" id="{9A386A77-7641-4E2E-8CA7-368AD3218828}"/>
               </a:ext>
             </a:extLst>
           </p:cNvPr>
@@ -2926,7 +2926,7 @@
           <p:cNvPr id="2" name="Left column">
             <a:extLst xmlns:a="http://schemas.openxmlformats.org/drawingml/2006/main">
               <a:ext uri="{FF2B5EF4-FFF2-40B4-BE49-F238E27FC236}">
-                <a16:creationId xmlns:a16="http://schemas.microsoft.com/office/drawing/2014/main" id="{4F9206FD-4290-438B-BE0A-5C14F9FEF4B3}"/>
+                <a16:creationId xmlns:a16="http://schemas.microsoft.com/office/drawing/2014/main" id="{FA128637-BB06-42AA-89C0-94FADE18A0C8}"/>
               </a:ext>
             </a:extLst>
           </p:cNvPr>
@@ -3083,7 +3083,7 @@
           <p:cNvPr id="3" name="Right column">
             <a:extLst xmlns:a="http://schemas.openxmlformats.org/drawingml/2006/main">
               <a:ext uri="{FF2B5EF4-FFF2-40B4-BE49-F238E27FC236}">
-                <a16:creationId xmlns:a16="http://schemas.microsoft.com/office/drawing/2014/main" id="{70D47C77-73D1-4EE4-9448-82F948DA6EA1}"/>
+                <a16:creationId xmlns:a16="http://schemas.microsoft.com/office/drawing/2014/main" id="{1C7B0271-1CAD-401E-BCD8-F38D4AFD7DDB}"/>
               </a:ext>
             </a:extLst>
           </p:cNvPr>
@@ -3257,7 +3257,7 @@
           <p:cNvPr id="3" name="Title">
             <a:extLst xmlns:a="http://schemas.openxmlformats.org/drawingml/2006/main">
               <a:ext uri="{FF2B5EF4-FFF2-40B4-BE49-F238E27FC236}">
-                <a16:creationId xmlns:a16="http://schemas.microsoft.com/office/drawing/2014/main" id="{8EAB10DC-EFDB-43CE-AF9A-1E64F12FA99C}"/>
+                <a16:creationId xmlns:a16="http://schemas.microsoft.com/office/drawing/2014/main" id="{469FD129-5922-4486-A475-F0D90028E150}"/>
               </a:ext>
             </a:extLst>
           </p:cNvPr>
@@ -3414,7 +3414,7 @@
           <p:cNvPr id="2" name="Left column">
             <a:extLst xmlns:a="http://schemas.openxmlformats.org/drawingml/2006/main">
               <a:ext uri="{FF2B5EF4-FFF2-40B4-BE49-F238E27FC236}">
-                <a16:creationId xmlns:a16="http://schemas.microsoft.com/office/drawing/2014/main" id="{B0C35A26-BAEE-49B1-A876-CF61BBBFF693}"/>
+                <a16:creationId xmlns:a16="http://schemas.microsoft.com/office/drawing/2014/main" id="{087B4344-0BDC-43A1-8955-41F68F2F00ED}"/>
               </a:ext>
             </a:extLst>
           </p:cNvPr>
@@ -3609,12 +3609,12 @@
   </p:cSld>
   <p:clrMap bg1="lt1" tx1="dk1" bg2="lt2" tx2="dk2" accent1="accent1" accent2="accent2" accent3="accent3" accent4="accent4" accent5="accent5" accent6="accent6" hlink="hlink" folHlink="folHlink"/>
   <p:sldLayoutIdLst>
-    <p:sldLayoutId xmlns:r="http://schemas.openxmlformats.org/officeDocument/2006/relationships" id="2147483649" r:id="R43b82bfd18c94a24"/>
-    <p:sldLayoutId xmlns:r="http://schemas.openxmlformats.org/officeDocument/2006/relationships" id="2147483650" r:id="Re49843e0a0dd4889"/>
-    <p:sldLayoutId xmlns:r="http://schemas.openxmlformats.org/officeDocument/2006/relationships" id="2147483651" r:id="Rbc0f7393a5da4ed8"/>
-    <p:sldLayoutId xmlns:r="http://schemas.openxmlformats.org/officeDocument/2006/relationships" id="2147483652" r:id="Re12177eb5ca743ac"/>
-    <p:sldLayoutId xmlns:r="http://schemas.openxmlformats.org/officeDocument/2006/relationships" id="2147483653" r:id="Rc527a7085172423c"/>
-    <p:sldLayoutId xmlns:r="http://schemas.openxmlformats.org/officeDocument/2006/relationships" id="2147483654" r:id="R0943a2e867b64916"/>
+    <p:sldLayoutId xmlns:r="http://schemas.openxmlformats.org/officeDocument/2006/relationships" id="2147483649" r:id="R38b5093d62904aed"/>
+    <p:sldLayoutId xmlns:r="http://schemas.openxmlformats.org/officeDocument/2006/relationships" id="2147483650" r:id="R18028add24454f1d"/>
+    <p:sldLayoutId xmlns:r="http://schemas.openxmlformats.org/officeDocument/2006/relationships" id="2147483651" r:id="R741dd1bbb33c4e94"/>
+    <p:sldLayoutId xmlns:r="http://schemas.openxmlformats.org/officeDocument/2006/relationships" id="2147483652" r:id="Ra2f75826befe4089"/>
+    <p:sldLayoutId xmlns:r="http://schemas.openxmlformats.org/officeDocument/2006/relationships" id="2147483653" r:id="R18cf69d4709748ef"/>
+    <p:sldLayoutId xmlns:r="http://schemas.openxmlformats.org/officeDocument/2006/relationships" id="2147483654" r:id="R4427a3429a544fd3"/>
   </p:sldLayoutIdLst>
   <p:txStyles>
     <p:titleStyle>
@@ -4165,7 +4165,7 @@
           <p:cNvPr id="5" name="">
             <a:extLst xmlns:a="http://schemas.openxmlformats.org/drawingml/2006/main">
               <a:ext uri="{FF2B5EF4-FFF2-40B4-BE49-F238E27FC236}">
-                <a16:creationId xmlns:a16="http://schemas.microsoft.com/office/drawing/2014/main" id="{7B3FF9B1-54E6-41E7-818C-F2B158C795AC}"/>
+                <a16:creationId xmlns:a16="http://schemas.microsoft.com/office/drawing/2014/main" id="{27428409-5601-4BAC-BDE8-324B608D4279}"/>
               </a:ext>
             </a:extLst>
           </p:cNvPr>
@@ -4175,7 +4175,7 @@
           <p:nvPr/>
         </p:nvPicPr>
         <p:blipFill>
-          <a:blip xmlns:r="http://schemas.openxmlformats.org/officeDocument/2006/relationships" xmlns:a="http://schemas.openxmlformats.org/drawingml/2006/main" r:embed="R6ffd88b864444761"/>
+          <a:blip xmlns:r="http://schemas.openxmlformats.org/officeDocument/2006/relationships" xmlns:a="http://schemas.openxmlformats.org/drawingml/2006/main" r:embed="R6bbf6bfadd504e66"/>
           <a:srcRect xmlns:a="http://schemas.openxmlformats.org/drawingml/2006/main" l="0" t="27" r="0" b="27"/>
           <a:stretch xmlns:a="http://schemas.openxmlformats.org/drawingml/2006/main">
             <a:fillRect l="0" t="0" r="0" b="0"/>
@@ -4196,7 +4196,7 @@
           <p:cNvPr id="2" name="">
             <a:extLst xmlns:a="http://schemas.openxmlformats.org/drawingml/2006/main">
               <a:ext uri="{FF2B5EF4-FFF2-40B4-BE49-F238E27FC236}">
-                <a16:creationId xmlns:a16="http://schemas.microsoft.com/office/drawing/2014/main" id="{736B0991-C871-428C-9A2B-95A56BFAB900}"/>
+                <a16:creationId xmlns:a16="http://schemas.microsoft.com/office/drawing/2014/main" id="{02724388-1941-4996-AB53-5BC410AD0AF4}"/>
               </a:ext>
             </a:extLst>
           </p:cNvPr>
@@ -4254,7 +4254,7 @@
                 <a:ea typeface="Microsoft JhengHei"/>
                 <a:cs typeface="Microsoft JhengHei"/>
               </a:rPr>
-              <a:t>放學路上的</a:t>
+              <a:t>楊光梅好、</a:t>
             </a:r>
           </a:p>
           <a:p xmlns:a="http://schemas.openxmlformats.org/drawingml/2006/main">
@@ -4277,7 +4277,7 @@
                 <a:ea typeface="Microsoft JhengHei"/>
                 <a:cs typeface="Microsoft JhengHei"/>
               </a:rPr>
-              <a:t>安全選擇</a:t>
+              <a:t>安全第一</a:t>
             </a:r>
           </a:p>
         </p:txBody>
@@ -4287,7 +4287,7 @@
           <p:cNvPr id="3" name="">
             <a:extLst xmlns:a="http://schemas.openxmlformats.org/drawingml/2006/main">
               <a:ext uri="{FF2B5EF4-FFF2-40B4-BE49-F238E27FC236}">
-                <a16:creationId xmlns:a16="http://schemas.microsoft.com/office/drawing/2014/main" id="{8CDC0113-591D-4908-9F58-A13AE3C7A40C}"/>
+                <a16:creationId xmlns:a16="http://schemas.microsoft.com/office/drawing/2014/main" id="{417288DF-7174-4656-B36E-3C7300669E47}"/>
               </a:ext>
             </a:extLst>
           </p:cNvPr>
@@ -4298,8 +4298,8 @@
         </p:nvSpPr>
         <p:spPr>
           <a:xfrm xmlns:a="http://schemas.openxmlformats.org/drawingml/2006/main">
-            <a:off x="666750" y="4238625"/>
-            <a:ext cx="5619750" cy="952500"/>
+            <a:off x="666750" y="4171950"/>
+            <a:ext cx="5810250" cy="1381125"/>
           </a:xfrm>
           <a:prstGeom xmlns:a="http://schemas.openxmlformats.org/drawingml/2006/main" prst="rect">
             <a:avLst/>
@@ -4315,7 +4315,7 @@
           </a:bodyPr>
           <a:lstStyle xmlns:a="http://schemas.openxmlformats.org/drawingml/2006/main">
             <a:defPPr>
-              <a:defRPr sz="2100" b="0">
+              <a:defRPr sz="1875" b="0">
                 <a:solidFill>
                   <a:srgbClr val="FFFFFF"/>
                 </a:solidFill>
@@ -4327,7 +4327,7 @@
           </a:lstStyle>
           <a:p xmlns:a="http://schemas.openxmlformats.org/drawingml/2006/main">
             <a:pPr>
-              <a:defRPr sz="2100" b="0">
+              <a:defRPr sz="1875" b="0">
                 <a:solidFill>
                   <a:srgbClr val="FFFFFF"/>
                 </a:solidFill>
@@ -4337,7 +4337,7 @@
               </a:defRPr>
             </a:pPr>
             <a:r>
-              <a:rPr sz="2100" b="0">
+              <a:rPr sz="1875" b="0">
                 <a:solidFill>
                   <a:srgbClr val="FFFFFF"/>
                 </a:solidFill>
@@ -4345,7 +4345,53 @@
                 <a:ea typeface="Microsoft JhengHei"/>
                 <a:cs typeface="Microsoft JhengHei"/>
               </a:rPr>
-              <a:t>楊梅高中交通安全充實課程</a:t>
+              <a:t>桃園市立楊梅高級中等學校</a:t>
+            </a:r>
+          </a:p>
+          <a:p xmlns:a="http://schemas.openxmlformats.org/drawingml/2006/main">
+            <a:pPr>
+              <a:defRPr sz="1875" b="0">
+                <a:solidFill>
+                  <a:srgbClr val="FFFFFF"/>
+                </a:solidFill>
+                <a:latin typeface="Microsoft JhengHei"/>
+                <a:ea typeface="Microsoft JhengHei"/>
+                <a:cs typeface="Microsoft JhengHei"/>
+              </a:defRPr>
+            </a:pPr>
+            <a:r>
+              <a:rPr sz="1875" b="0">
+                <a:solidFill>
+                  <a:srgbClr val="FFFFFF"/>
+                </a:solidFill>
+                <a:latin typeface="Microsoft JhengHei"/>
+                <a:ea typeface="Microsoft JhengHei"/>
+                <a:cs typeface="Microsoft JhengHei"/>
+              </a:rPr>
+              <a:t>高二交通安全充實課程</a:t>
+            </a:r>
+          </a:p>
+          <a:p xmlns:a="http://schemas.openxmlformats.org/drawingml/2006/main">
+            <a:pPr>
+              <a:defRPr sz="1875" b="0">
+                <a:solidFill>
+                  <a:srgbClr val="FFFFFF"/>
+                </a:solidFill>
+                <a:latin typeface="Microsoft JhengHei"/>
+                <a:ea typeface="Microsoft JhengHei"/>
+                <a:cs typeface="Microsoft JhengHei"/>
+              </a:defRPr>
+            </a:pPr>
+            <a:r>
+              <a:rPr sz="1875" b="0">
+                <a:solidFill>
+                  <a:srgbClr val="FFFFFF"/>
+                </a:solidFill>
+                <a:latin typeface="Microsoft JhengHei"/>
+                <a:ea typeface="Microsoft JhengHei"/>
+                <a:cs typeface="Microsoft JhengHei"/>
+              </a:rPr>
+              <a:t>分組活動版</a:t>
             </a:r>
           </a:p>
         </p:txBody>
@@ -4355,7 +4401,7 @@
           <p:cNvPr id="4" name="">
             <a:extLst xmlns:a="http://schemas.openxmlformats.org/drawingml/2006/main">
               <a:ext uri="{FF2B5EF4-FFF2-40B4-BE49-F238E27FC236}">
-                <a16:creationId xmlns:a16="http://schemas.microsoft.com/office/drawing/2014/main" id="{B1CD14E1-2FDF-4520-B780-7DD9C311559A}"/>
+                <a16:creationId xmlns:a16="http://schemas.microsoft.com/office/drawing/2014/main" id="{D7AC518C-88D4-4066-81A3-C1C642A8479A}"/>
               </a:ext>
             </a:extLst>
           </p:cNvPr>
@@ -4421,7 +4467,7 @@
     </p:spTree>
     <p:extLst>
       <p:ext uri="{BB962C8B-B14F-4D97-AF65-F5344CB8AC3E}">
-        <p14:creationId xmlns:p14="http://schemas.microsoft.com/office/powerpoint/2010/main" val="1387306692"/>
+        <p14:creationId xmlns:p14="http://schemas.microsoft.com/office/powerpoint/2010/main" val="332487411"/>
       </p:ext>
     </p:extLst>
   </p:cSld>
@@ -4452,7 +4498,7 @@
           <p:cNvPr id="7" name="">
             <a:extLst xmlns:a="http://schemas.openxmlformats.org/drawingml/2006/main">
               <a:ext uri="{FF2B5EF4-FFF2-40B4-BE49-F238E27FC236}">
-                <a16:creationId xmlns:a16="http://schemas.microsoft.com/office/drawing/2014/main" id="{B5C3B8DA-7FC7-4377-A9A0-976E07497B61}"/>
+                <a16:creationId xmlns:a16="http://schemas.microsoft.com/office/drawing/2014/main" id="{C8CC32AE-68E3-4137-997F-A8A077F421AC}"/>
               </a:ext>
             </a:extLst>
           </p:cNvPr>
@@ -4520,7 +4566,7 @@
           <p:cNvPr id="2" name="">
             <a:extLst xmlns:a="http://schemas.openxmlformats.org/drawingml/2006/main">
               <a:ext uri="{FF2B5EF4-FFF2-40B4-BE49-F238E27FC236}">
-                <a16:creationId xmlns:a16="http://schemas.microsoft.com/office/drawing/2014/main" id="{273C503B-71AB-4ED9-942E-0092DEE79F0F}"/>
+                <a16:creationId xmlns:a16="http://schemas.microsoft.com/office/drawing/2014/main" id="{22BFE48B-E6BE-4359-AF5B-14EDE20DE777}"/>
               </a:ext>
             </a:extLst>
           </p:cNvPr>
@@ -4588,7 +4634,7 @@
           <p:cNvPr id="3" name="">
             <a:extLst xmlns:a="http://schemas.openxmlformats.org/drawingml/2006/main">
               <a:ext uri="{FF2B5EF4-FFF2-40B4-BE49-F238E27FC236}">
-                <a16:creationId xmlns:a16="http://schemas.microsoft.com/office/drawing/2014/main" id="{AE005E56-7C1C-497A-BF52-FF26DB577520}"/>
+                <a16:creationId xmlns:a16="http://schemas.microsoft.com/office/drawing/2014/main" id="{8FCB3A2D-3174-4244-AA44-66CBFAC3D2E2}"/>
               </a:ext>
             </a:extLst>
           </p:cNvPr>
@@ -4656,7 +4702,7 @@
           <p:cNvPr id="4" name="">
             <a:extLst xmlns:a="http://schemas.openxmlformats.org/drawingml/2006/main">
               <a:ext uri="{FF2B5EF4-FFF2-40B4-BE49-F238E27FC236}">
-                <a16:creationId xmlns:a16="http://schemas.microsoft.com/office/drawing/2014/main" id="{07794D66-64B0-4EDA-8676-6FDA04603916}"/>
+                <a16:creationId xmlns:a16="http://schemas.microsoft.com/office/drawing/2014/main" id="{49201627-4EB0-454A-BA5C-72B879C61C1A}"/>
               </a:ext>
             </a:extLst>
           </p:cNvPr>
@@ -4724,7 +4770,7 @@
           <p:cNvPr id="5" name="">
             <a:extLst xmlns:a="http://schemas.openxmlformats.org/drawingml/2006/main">
               <a:ext uri="{FF2B5EF4-FFF2-40B4-BE49-F238E27FC236}">
-                <a16:creationId xmlns:a16="http://schemas.microsoft.com/office/drawing/2014/main" id="{1642FFA7-A72C-4FC7-901D-927B1C0A4646}"/>
+                <a16:creationId xmlns:a16="http://schemas.microsoft.com/office/drawing/2014/main" id="{EDF42F6B-7508-4B69-8AFA-52FC64107EE9}"/>
               </a:ext>
             </a:extLst>
           </p:cNvPr>
@@ -4792,7 +4838,7 @@
           <p:cNvPr id="6" name="">
             <a:extLst xmlns:a="http://schemas.openxmlformats.org/drawingml/2006/main">
               <a:ext uri="{FF2B5EF4-FFF2-40B4-BE49-F238E27FC236}">
-                <a16:creationId xmlns:a16="http://schemas.microsoft.com/office/drawing/2014/main" id="{E144FFC9-C0ED-41A6-B963-D2A97FCCEA04}"/>
+                <a16:creationId xmlns:a16="http://schemas.microsoft.com/office/drawing/2014/main" id="{BE63B288-B0A9-40DC-ACC0-1DA67DC0DFF4}"/>
               </a:ext>
             </a:extLst>
           </p:cNvPr>
@@ -4858,7 +4904,7 @@
     </p:spTree>
     <p:extLst>
       <p:ext uri="{BB962C8B-B14F-4D97-AF65-F5344CB8AC3E}">
-        <p14:creationId xmlns:p14="http://schemas.microsoft.com/office/powerpoint/2010/main" val="308583436"/>
+        <p14:creationId xmlns:p14="http://schemas.microsoft.com/office/powerpoint/2010/main" val="1530720303"/>
       </p:ext>
     </p:extLst>
   </p:cSld>
@@ -4889,7 +4935,7 @@
           <p:cNvPr id="6" name="">
             <a:extLst xmlns:a="http://schemas.openxmlformats.org/drawingml/2006/main">
               <a:ext uri="{FF2B5EF4-FFF2-40B4-BE49-F238E27FC236}">
-                <a16:creationId xmlns:a16="http://schemas.microsoft.com/office/drawing/2014/main" id="{1CB8D6F6-F034-4EE3-807F-BED4CD1282CA}"/>
+                <a16:creationId xmlns:a16="http://schemas.microsoft.com/office/drawing/2014/main" id="{A69631EE-24A6-4A63-AF47-1A91700D63CA}"/>
               </a:ext>
             </a:extLst>
           </p:cNvPr>
@@ -4957,7 +5003,7 @@
           <p:cNvPr id="2" name="">
             <a:extLst xmlns:a="http://schemas.openxmlformats.org/drawingml/2006/main">
               <a:ext uri="{FF2B5EF4-FFF2-40B4-BE49-F238E27FC236}">
-                <a16:creationId xmlns:a16="http://schemas.microsoft.com/office/drawing/2014/main" id="{9D7ABB70-2E10-4585-9ABF-9D16A98B89C8}"/>
+                <a16:creationId xmlns:a16="http://schemas.microsoft.com/office/drawing/2014/main" id="{4200DBCB-9423-47D1-A5E4-19BE0EDA7B77}"/>
               </a:ext>
             </a:extLst>
           </p:cNvPr>
@@ -5025,7 +5071,7 @@
           <p:cNvPr id="3" name="">
             <a:extLst xmlns:a="http://schemas.openxmlformats.org/drawingml/2006/main">
               <a:ext uri="{FF2B5EF4-FFF2-40B4-BE49-F238E27FC236}">
-                <a16:creationId xmlns:a16="http://schemas.microsoft.com/office/drawing/2014/main" id="{D2BA4BBB-2EB4-46AC-84F4-2F5D931A6483}"/>
+                <a16:creationId xmlns:a16="http://schemas.microsoft.com/office/drawing/2014/main" id="{8980CE4A-47E3-4E5D-BCF5-344A771D8880}"/>
               </a:ext>
             </a:extLst>
           </p:cNvPr>
@@ -5093,7 +5139,7 @@
           <p:cNvPr id="4" name="">
             <a:extLst xmlns:a="http://schemas.openxmlformats.org/drawingml/2006/main">
               <a:ext uri="{FF2B5EF4-FFF2-40B4-BE49-F238E27FC236}">
-                <a16:creationId xmlns:a16="http://schemas.microsoft.com/office/drawing/2014/main" id="{1870B591-76D7-472E-B3F7-55DD0D7DA292}"/>
+                <a16:creationId xmlns:a16="http://schemas.microsoft.com/office/drawing/2014/main" id="{2E3283E3-46FB-4EFA-9FA6-2DE680516E28}"/>
               </a:ext>
             </a:extLst>
           </p:cNvPr>
@@ -5150,7 +5196,7 @@
                 <a:latin typeface="Microsoft JhengHei"/>
                 <a:ea typeface="Microsoft JhengHei"/>
                 <a:cs typeface="Microsoft JhengHei"/>
-                <a:hlinkClick xmlns:r="http://schemas.openxmlformats.org/officeDocument/2006/relationships" r:id="R3b0fcba3c6924426"/>
+                <a:hlinkClick xmlns:r="http://schemas.openxmlformats.org/officeDocument/2006/relationships" r:id="R950ea8218ebc43d6"/>
               </a:rPr>
               <a:t>公視新聞網　2024.02.13</a:t>
             </a:r>
@@ -5174,7 +5220,7 @@
                 <a:latin typeface="Microsoft JhengHei"/>
                 <a:ea typeface="Microsoft JhengHei"/>
                 <a:cs typeface="Microsoft JhengHei"/>
-                <a:hlinkClick xmlns:r="http://schemas.openxmlformats.org/officeDocument/2006/relationships" r:id="R0cef857998ec4a05"/>
+                <a:hlinkClick xmlns:r="http://schemas.openxmlformats.org/officeDocument/2006/relationships" r:id="Rab96e42e3cd1435d"/>
               </a:rPr>
               <a:t>點選觀看新聞片段</a:t>
             </a:r>
@@ -5186,7 +5232,7 @@
           <p:cNvPr id="5" name="">
             <a:extLst xmlns:a="http://schemas.openxmlformats.org/drawingml/2006/main">
               <a:ext uri="{FF2B5EF4-FFF2-40B4-BE49-F238E27FC236}">
-                <a16:creationId xmlns:a16="http://schemas.microsoft.com/office/drawing/2014/main" id="{23E6A381-CC1B-4CA8-8E7E-5B1F84164CCA}"/>
+                <a16:creationId xmlns:a16="http://schemas.microsoft.com/office/drawing/2014/main" id="{C091F884-9309-4D5D-840E-5FB92FABE461}"/>
               </a:ext>
             </a:extLst>
           </p:cNvPr>
@@ -5252,7 +5298,7 @@
     </p:spTree>
     <p:extLst>
       <p:ext uri="{BB962C8B-B14F-4D97-AF65-F5344CB8AC3E}">
-        <p14:creationId xmlns:p14="http://schemas.microsoft.com/office/powerpoint/2010/main" val="957184763"/>
+        <p14:creationId xmlns:p14="http://schemas.microsoft.com/office/powerpoint/2010/main" val="2084510610"/>
       </p:ext>
     </p:extLst>
   </p:cSld>
@@ -5283,7 +5329,7 @@
           <p:cNvPr id="7" name="">
             <a:extLst xmlns:a="http://schemas.openxmlformats.org/drawingml/2006/main">
               <a:ext uri="{FF2B5EF4-FFF2-40B4-BE49-F238E27FC236}">
-                <a16:creationId xmlns:a16="http://schemas.microsoft.com/office/drawing/2014/main" id="{63FB33E7-75F0-4A03-B6FB-659D255F1221}"/>
+                <a16:creationId xmlns:a16="http://schemas.microsoft.com/office/drawing/2014/main" id="{3BA0F9EE-F3C6-47E6-A099-973D8C0A260F}"/>
               </a:ext>
             </a:extLst>
           </p:cNvPr>
@@ -5351,7 +5397,7 @@
           <p:cNvPr id="2" name="">
             <a:extLst xmlns:a="http://schemas.openxmlformats.org/drawingml/2006/main">
               <a:ext uri="{FF2B5EF4-FFF2-40B4-BE49-F238E27FC236}">
-                <a16:creationId xmlns:a16="http://schemas.microsoft.com/office/drawing/2014/main" id="{21C215A8-48C9-4C07-A6ED-95AAA551848A}"/>
+                <a16:creationId xmlns:a16="http://schemas.microsoft.com/office/drawing/2014/main" id="{A287776D-2E42-4945-901D-0B96CAA5CB7F}"/>
               </a:ext>
             </a:extLst>
           </p:cNvPr>
@@ -5419,7 +5465,7 @@
           <p:cNvPr id="3" name="">
             <a:extLst xmlns:a="http://schemas.openxmlformats.org/drawingml/2006/main">
               <a:ext uri="{FF2B5EF4-FFF2-40B4-BE49-F238E27FC236}">
-                <a16:creationId xmlns:a16="http://schemas.microsoft.com/office/drawing/2014/main" id="{264AD4C2-802B-423E-B22F-FC350AA42335}"/>
+                <a16:creationId xmlns:a16="http://schemas.microsoft.com/office/drawing/2014/main" id="{128865FB-AB9A-4806-AED6-2ED55FDE195D}"/>
               </a:ext>
             </a:extLst>
           </p:cNvPr>
@@ -5487,7 +5533,7 @@
           <p:cNvPr id="4" name="">
             <a:extLst xmlns:a="http://schemas.openxmlformats.org/drawingml/2006/main">
               <a:ext uri="{FF2B5EF4-FFF2-40B4-BE49-F238E27FC236}">
-                <a16:creationId xmlns:a16="http://schemas.microsoft.com/office/drawing/2014/main" id="{3617D5A4-4263-4D9F-A948-E414F0CFE3A2}"/>
+                <a16:creationId xmlns:a16="http://schemas.microsoft.com/office/drawing/2014/main" id="{641AD054-A536-4F56-9734-27B3230073D0}"/>
               </a:ext>
             </a:extLst>
           </p:cNvPr>
@@ -5555,7 +5601,7 @@
           <p:cNvPr id="5" name="">
             <a:extLst xmlns:a="http://schemas.openxmlformats.org/drawingml/2006/main">
               <a:ext uri="{FF2B5EF4-FFF2-40B4-BE49-F238E27FC236}">
-                <a16:creationId xmlns:a16="http://schemas.microsoft.com/office/drawing/2014/main" id="{3EDED770-85F4-4A6B-86CF-86BFC17B6857}"/>
+                <a16:creationId xmlns:a16="http://schemas.microsoft.com/office/drawing/2014/main" id="{9C45BD66-68DE-4DC7-BB33-920F0AAB8137}"/>
               </a:ext>
             </a:extLst>
           </p:cNvPr>
@@ -5623,7 +5669,7 @@
           <p:cNvPr id="6" name="">
             <a:extLst xmlns:a="http://schemas.openxmlformats.org/drawingml/2006/main">
               <a:ext uri="{FF2B5EF4-FFF2-40B4-BE49-F238E27FC236}">
-                <a16:creationId xmlns:a16="http://schemas.microsoft.com/office/drawing/2014/main" id="{F6F5E545-BCB7-4CD5-9F44-EFA8E3A2A0CF}"/>
+                <a16:creationId xmlns:a16="http://schemas.microsoft.com/office/drawing/2014/main" id="{2FDA38D3-F978-478C-B7B2-28A1978B7FC3}"/>
               </a:ext>
             </a:extLst>
           </p:cNvPr>
@@ -5689,7 +5735,7 @@
     </p:spTree>
     <p:extLst>
       <p:ext uri="{BB962C8B-B14F-4D97-AF65-F5344CB8AC3E}">
-        <p14:creationId xmlns:p14="http://schemas.microsoft.com/office/powerpoint/2010/main" val="1320725707"/>
+        <p14:creationId xmlns:p14="http://schemas.microsoft.com/office/powerpoint/2010/main" val="2033382075"/>
       </p:ext>
     </p:extLst>
   </p:cSld>
@@ -5720,7 +5766,7 @@
           <p:cNvPr id="7" name="">
             <a:extLst xmlns:a="http://schemas.openxmlformats.org/drawingml/2006/main">
               <a:ext uri="{FF2B5EF4-FFF2-40B4-BE49-F238E27FC236}">
-                <a16:creationId xmlns:a16="http://schemas.microsoft.com/office/drawing/2014/main" id="{0A2945F2-2BD8-47FD-A8F6-2623EE13F263}"/>
+                <a16:creationId xmlns:a16="http://schemas.microsoft.com/office/drawing/2014/main" id="{03006BF8-F613-44DA-9AEF-10D779B22D5F}"/>
               </a:ext>
             </a:extLst>
           </p:cNvPr>
@@ -5788,7 +5834,7 @@
           <p:cNvPr id="2" name="">
             <a:extLst xmlns:a="http://schemas.openxmlformats.org/drawingml/2006/main">
               <a:ext uri="{FF2B5EF4-FFF2-40B4-BE49-F238E27FC236}">
-                <a16:creationId xmlns:a16="http://schemas.microsoft.com/office/drawing/2014/main" id="{13D150FC-BA48-4FF8-BB89-A4365CAF6739}"/>
+                <a16:creationId xmlns:a16="http://schemas.microsoft.com/office/drawing/2014/main" id="{0875483A-EC54-4387-9713-CA11DA1506C0}"/>
               </a:ext>
             </a:extLst>
           </p:cNvPr>
@@ -5856,7 +5902,7 @@
           <p:cNvPr id="3" name="">
             <a:extLst xmlns:a="http://schemas.openxmlformats.org/drawingml/2006/main">
               <a:ext uri="{FF2B5EF4-FFF2-40B4-BE49-F238E27FC236}">
-                <a16:creationId xmlns:a16="http://schemas.microsoft.com/office/drawing/2014/main" id="{5CCF32D3-3360-4326-A730-44A3569CE209}"/>
+                <a16:creationId xmlns:a16="http://schemas.microsoft.com/office/drawing/2014/main" id="{D78DA406-5B1A-46E8-BBB3-583AE4BAE484}"/>
               </a:ext>
             </a:extLst>
           </p:cNvPr>
@@ -5924,7 +5970,7 @@
           <p:cNvPr id="4" name="">
             <a:extLst xmlns:a="http://schemas.openxmlformats.org/drawingml/2006/main">
               <a:ext uri="{FF2B5EF4-FFF2-40B4-BE49-F238E27FC236}">
-                <a16:creationId xmlns:a16="http://schemas.microsoft.com/office/drawing/2014/main" id="{CBFB1FDA-228C-4C00-B64E-11A8DB4FBFCE}"/>
+                <a16:creationId xmlns:a16="http://schemas.microsoft.com/office/drawing/2014/main" id="{29D2141A-179F-4678-A358-95DB66F243CF}"/>
               </a:ext>
             </a:extLst>
           </p:cNvPr>
@@ -5992,7 +6038,7 @@
           <p:cNvPr id="5" name="">
             <a:extLst xmlns:a="http://schemas.openxmlformats.org/drawingml/2006/main">
               <a:ext uri="{FF2B5EF4-FFF2-40B4-BE49-F238E27FC236}">
-                <a16:creationId xmlns:a16="http://schemas.microsoft.com/office/drawing/2014/main" id="{B6A3867A-5D0D-4572-AB00-83F9FC95F046}"/>
+                <a16:creationId xmlns:a16="http://schemas.microsoft.com/office/drawing/2014/main" id="{FFE65A0C-6AAC-4405-911A-E306594E03DE}"/>
               </a:ext>
             </a:extLst>
           </p:cNvPr>
@@ -6060,7 +6106,7 @@
           <p:cNvPr id="6" name="">
             <a:extLst xmlns:a="http://schemas.openxmlformats.org/drawingml/2006/main">
               <a:ext uri="{FF2B5EF4-FFF2-40B4-BE49-F238E27FC236}">
-                <a16:creationId xmlns:a16="http://schemas.microsoft.com/office/drawing/2014/main" id="{68AE1777-DF56-42F3-8712-ABC3148DD433}"/>
+                <a16:creationId xmlns:a16="http://schemas.microsoft.com/office/drawing/2014/main" id="{0A2F4351-69C0-45B7-B819-22848E456E03}"/>
               </a:ext>
             </a:extLst>
           </p:cNvPr>
@@ -6126,7 +6172,7 @@
     </p:spTree>
     <p:extLst>
       <p:ext uri="{BB962C8B-B14F-4D97-AF65-F5344CB8AC3E}">
-        <p14:creationId xmlns:p14="http://schemas.microsoft.com/office/powerpoint/2010/main" val="1666677800"/>
+        <p14:creationId xmlns:p14="http://schemas.microsoft.com/office/powerpoint/2010/main" val="1542873533"/>
       </p:ext>
     </p:extLst>
   </p:cSld>
@@ -6157,7 +6203,7 @@
           <p:cNvPr id="7" name="">
             <a:extLst xmlns:a="http://schemas.openxmlformats.org/drawingml/2006/main">
               <a:ext uri="{FF2B5EF4-FFF2-40B4-BE49-F238E27FC236}">
-                <a16:creationId xmlns:a16="http://schemas.microsoft.com/office/drawing/2014/main" id="{2E80C574-C8F4-4712-BB06-B026326044B0}"/>
+                <a16:creationId xmlns:a16="http://schemas.microsoft.com/office/drawing/2014/main" id="{5E1B5B52-4B1E-4FC7-A61A-08D0614AF128}"/>
               </a:ext>
             </a:extLst>
           </p:cNvPr>
@@ -6225,7 +6271,7 @@
           <p:cNvPr id="2" name="">
             <a:extLst xmlns:a="http://schemas.openxmlformats.org/drawingml/2006/main">
               <a:ext uri="{FF2B5EF4-FFF2-40B4-BE49-F238E27FC236}">
-                <a16:creationId xmlns:a16="http://schemas.microsoft.com/office/drawing/2014/main" id="{60E217D2-6A8F-4F94-A56A-C2346BE49A01}"/>
+                <a16:creationId xmlns:a16="http://schemas.microsoft.com/office/drawing/2014/main" id="{17859AF1-6CFB-45B1-8EB6-86E11216E30D}"/>
               </a:ext>
             </a:extLst>
           </p:cNvPr>
@@ -6293,7 +6339,7 @@
           <p:cNvPr id="3" name="">
             <a:extLst xmlns:a="http://schemas.openxmlformats.org/drawingml/2006/main">
               <a:ext uri="{FF2B5EF4-FFF2-40B4-BE49-F238E27FC236}">
-                <a16:creationId xmlns:a16="http://schemas.microsoft.com/office/drawing/2014/main" id="{EF1FA72A-FDF2-445C-BB72-0F038AC4D2EC}"/>
+                <a16:creationId xmlns:a16="http://schemas.microsoft.com/office/drawing/2014/main" id="{2FC1CF46-B011-49FF-9D03-AE9E8F81C22E}"/>
               </a:ext>
             </a:extLst>
           </p:cNvPr>
@@ -6361,7 +6407,7 @@
           <p:cNvPr id="4" name="">
             <a:extLst xmlns:a="http://schemas.openxmlformats.org/drawingml/2006/main">
               <a:ext uri="{FF2B5EF4-FFF2-40B4-BE49-F238E27FC236}">
-                <a16:creationId xmlns:a16="http://schemas.microsoft.com/office/drawing/2014/main" id="{7066F495-9830-48B5-9B7E-48EF6D8EF29D}"/>
+                <a16:creationId xmlns:a16="http://schemas.microsoft.com/office/drawing/2014/main" id="{6F062079-A4B1-4ADA-9199-5B9ADAAC0E29}"/>
               </a:ext>
             </a:extLst>
           </p:cNvPr>
@@ -6429,7 +6475,7 @@
           <p:cNvPr id="5" name="">
             <a:extLst xmlns:a="http://schemas.openxmlformats.org/drawingml/2006/main">
               <a:ext uri="{FF2B5EF4-FFF2-40B4-BE49-F238E27FC236}">
-                <a16:creationId xmlns:a16="http://schemas.microsoft.com/office/drawing/2014/main" id="{22A005B9-E471-4BD8-8548-D319FA47AAC6}"/>
+                <a16:creationId xmlns:a16="http://schemas.microsoft.com/office/drawing/2014/main" id="{CECBE493-676F-4BE1-B147-4F7BEFDB1AFC}"/>
               </a:ext>
             </a:extLst>
           </p:cNvPr>
@@ -6497,7 +6543,7 @@
           <p:cNvPr id="6" name="">
             <a:extLst xmlns:a="http://schemas.openxmlformats.org/drawingml/2006/main">
               <a:ext uri="{FF2B5EF4-FFF2-40B4-BE49-F238E27FC236}">
-                <a16:creationId xmlns:a16="http://schemas.microsoft.com/office/drawing/2014/main" id="{10E847E7-A89E-4591-8357-559E2BF1E7E5}"/>
+                <a16:creationId xmlns:a16="http://schemas.microsoft.com/office/drawing/2014/main" id="{85E9AAB5-3CE0-4D00-A0B7-0ECD70046114}"/>
               </a:ext>
             </a:extLst>
           </p:cNvPr>
@@ -6563,7 +6609,7 @@
     </p:spTree>
     <p:extLst>
       <p:ext uri="{BB962C8B-B14F-4D97-AF65-F5344CB8AC3E}">
-        <p14:creationId xmlns:p14="http://schemas.microsoft.com/office/powerpoint/2010/main" val="1755792521"/>
+        <p14:creationId xmlns:p14="http://schemas.microsoft.com/office/powerpoint/2010/main" val="1665635202"/>
       </p:ext>
     </p:extLst>
   </p:cSld>
@@ -6594,7 +6640,7 @@
           <p:cNvPr id="7" name="">
             <a:extLst xmlns:a="http://schemas.openxmlformats.org/drawingml/2006/main">
               <a:ext uri="{FF2B5EF4-FFF2-40B4-BE49-F238E27FC236}">
-                <a16:creationId xmlns:a16="http://schemas.microsoft.com/office/drawing/2014/main" id="{45089801-FB62-416E-9F0B-AD646EDCC098}"/>
+                <a16:creationId xmlns:a16="http://schemas.microsoft.com/office/drawing/2014/main" id="{CAE19B27-5959-4EF6-9290-20E6275C9DDF}"/>
               </a:ext>
             </a:extLst>
           </p:cNvPr>
@@ -6662,7 +6708,7 @@
           <p:cNvPr id="2" name="">
             <a:extLst xmlns:a="http://schemas.openxmlformats.org/drawingml/2006/main">
               <a:ext uri="{FF2B5EF4-FFF2-40B4-BE49-F238E27FC236}">
-                <a16:creationId xmlns:a16="http://schemas.microsoft.com/office/drawing/2014/main" id="{640FF9C9-67D0-4F8B-88B9-51139B333550}"/>
+                <a16:creationId xmlns:a16="http://schemas.microsoft.com/office/drawing/2014/main" id="{2140BE8F-0B4E-43C1-B46F-837130926563}"/>
               </a:ext>
             </a:extLst>
           </p:cNvPr>
@@ -6730,7 +6776,7 @@
           <p:cNvPr id="3" name="">
             <a:extLst xmlns:a="http://schemas.openxmlformats.org/drawingml/2006/main">
               <a:ext uri="{FF2B5EF4-FFF2-40B4-BE49-F238E27FC236}">
-                <a16:creationId xmlns:a16="http://schemas.microsoft.com/office/drawing/2014/main" id="{96FF8ADB-D928-4882-9756-1D458FD08082}"/>
+                <a16:creationId xmlns:a16="http://schemas.microsoft.com/office/drawing/2014/main" id="{021259DE-CCED-4281-969D-CB45323409B0}"/>
               </a:ext>
             </a:extLst>
           </p:cNvPr>
@@ -6798,7 +6844,7 @@
           <p:cNvPr id="4" name="">
             <a:extLst xmlns:a="http://schemas.openxmlformats.org/drawingml/2006/main">
               <a:ext uri="{FF2B5EF4-FFF2-40B4-BE49-F238E27FC236}">
-                <a16:creationId xmlns:a16="http://schemas.microsoft.com/office/drawing/2014/main" id="{E21F7C7E-26E8-4932-9CB5-05FAD06394B5}"/>
+                <a16:creationId xmlns:a16="http://schemas.microsoft.com/office/drawing/2014/main" id="{159B850B-4A4D-4EC6-8BB5-EF3A1F6E41CF}"/>
               </a:ext>
             </a:extLst>
           </p:cNvPr>
@@ -6866,7 +6912,7 @@
           <p:cNvPr id="5" name="">
             <a:extLst xmlns:a="http://schemas.openxmlformats.org/drawingml/2006/main">
               <a:ext uri="{FF2B5EF4-FFF2-40B4-BE49-F238E27FC236}">
-                <a16:creationId xmlns:a16="http://schemas.microsoft.com/office/drawing/2014/main" id="{58410BE1-D0CE-4468-8E65-3709A672FF19}"/>
+                <a16:creationId xmlns:a16="http://schemas.microsoft.com/office/drawing/2014/main" id="{0641DA6B-C71F-46AC-B68F-DB6D43453D36}"/>
               </a:ext>
             </a:extLst>
           </p:cNvPr>
@@ -6934,7 +6980,7 @@
           <p:cNvPr id="6" name="">
             <a:extLst xmlns:a="http://schemas.openxmlformats.org/drawingml/2006/main">
               <a:ext uri="{FF2B5EF4-FFF2-40B4-BE49-F238E27FC236}">
-                <a16:creationId xmlns:a16="http://schemas.microsoft.com/office/drawing/2014/main" id="{704F6EDA-717D-4041-86FB-ED93EAF36C9A}"/>
+                <a16:creationId xmlns:a16="http://schemas.microsoft.com/office/drawing/2014/main" id="{D77374EF-36EB-4E97-86AF-505BBD6D2448}"/>
               </a:ext>
             </a:extLst>
           </p:cNvPr>
@@ -7000,7 +7046,7 @@
     </p:spTree>
     <p:extLst>
       <p:ext uri="{BB962C8B-B14F-4D97-AF65-F5344CB8AC3E}">
-        <p14:creationId xmlns:p14="http://schemas.microsoft.com/office/powerpoint/2010/main" val="1681659614"/>
+        <p14:creationId xmlns:p14="http://schemas.microsoft.com/office/powerpoint/2010/main" val="458979399"/>
       </p:ext>
     </p:extLst>
   </p:cSld>
@@ -7031,7 +7077,7 @@
           <p:cNvPr id="7" name="">
             <a:extLst xmlns:a="http://schemas.openxmlformats.org/drawingml/2006/main">
               <a:ext uri="{FF2B5EF4-FFF2-40B4-BE49-F238E27FC236}">
-                <a16:creationId xmlns:a16="http://schemas.microsoft.com/office/drawing/2014/main" id="{3B2AB4E6-3E79-48DA-8703-FDC094ABEF0E}"/>
+                <a16:creationId xmlns:a16="http://schemas.microsoft.com/office/drawing/2014/main" id="{6F6D7F15-60AD-4A36-9742-D7FBDDF8950C}"/>
               </a:ext>
             </a:extLst>
           </p:cNvPr>
@@ -7099,7 +7145,7 @@
           <p:cNvPr id="2" name="">
             <a:extLst xmlns:a="http://schemas.openxmlformats.org/drawingml/2006/main">
               <a:ext uri="{FF2B5EF4-FFF2-40B4-BE49-F238E27FC236}">
-                <a16:creationId xmlns:a16="http://schemas.microsoft.com/office/drawing/2014/main" id="{D7016720-8831-49B8-902E-2251E181C426}"/>
+                <a16:creationId xmlns:a16="http://schemas.microsoft.com/office/drawing/2014/main" id="{055456D9-F4DF-4D09-BD60-3B8C505B772A}"/>
               </a:ext>
             </a:extLst>
           </p:cNvPr>
@@ -7167,7 +7213,7 @@
           <p:cNvPr id="3" name="">
             <a:extLst xmlns:a="http://schemas.openxmlformats.org/drawingml/2006/main">
               <a:ext uri="{FF2B5EF4-FFF2-40B4-BE49-F238E27FC236}">
-                <a16:creationId xmlns:a16="http://schemas.microsoft.com/office/drawing/2014/main" id="{9B1FE046-474A-40CD-A87C-A7EF5E3DC6FD}"/>
+                <a16:creationId xmlns:a16="http://schemas.microsoft.com/office/drawing/2014/main" id="{19944D88-53CF-41A1-B57A-9A3896654644}"/>
               </a:ext>
             </a:extLst>
           </p:cNvPr>
@@ -7235,7 +7281,7 @@
           <p:cNvPr id="4" name="">
             <a:extLst xmlns:a="http://schemas.openxmlformats.org/drawingml/2006/main">
               <a:ext uri="{FF2B5EF4-FFF2-40B4-BE49-F238E27FC236}">
-                <a16:creationId xmlns:a16="http://schemas.microsoft.com/office/drawing/2014/main" id="{FC6F4F2B-C351-4899-8860-F1D8EF73F396}"/>
+                <a16:creationId xmlns:a16="http://schemas.microsoft.com/office/drawing/2014/main" id="{11D167CD-CC8F-4603-87CA-DBEED7CC38B5}"/>
               </a:ext>
             </a:extLst>
           </p:cNvPr>
@@ -7303,7 +7349,7 @@
           <p:cNvPr id="5" name="">
             <a:extLst xmlns:a="http://schemas.openxmlformats.org/drawingml/2006/main">
               <a:ext uri="{FF2B5EF4-FFF2-40B4-BE49-F238E27FC236}">
-                <a16:creationId xmlns:a16="http://schemas.microsoft.com/office/drawing/2014/main" id="{73E7A2F2-BF9F-4711-8E71-F867B709C2EC}"/>
+                <a16:creationId xmlns:a16="http://schemas.microsoft.com/office/drawing/2014/main" id="{4C224BE3-10CD-4BD5-AA32-3214562468E1}"/>
               </a:ext>
             </a:extLst>
           </p:cNvPr>
@@ -7371,7 +7417,7 @@
           <p:cNvPr id="6" name="">
             <a:extLst xmlns:a="http://schemas.openxmlformats.org/drawingml/2006/main">
               <a:ext uri="{FF2B5EF4-FFF2-40B4-BE49-F238E27FC236}">
-                <a16:creationId xmlns:a16="http://schemas.microsoft.com/office/drawing/2014/main" id="{5971E575-9283-45FF-9F26-7FC1648B831D}"/>
+                <a16:creationId xmlns:a16="http://schemas.microsoft.com/office/drawing/2014/main" id="{A7485AC2-C884-4F22-890D-F0BFCD3114AE}"/>
               </a:ext>
             </a:extLst>
           </p:cNvPr>
@@ -7437,7 +7483,7 @@
     </p:spTree>
     <p:extLst>
       <p:ext uri="{BB962C8B-B14F-4D97-AF65-F5344CB8AC3E}">
-        <p14:creationId xmlns:p14="http://schemas.microsoft.com/office/powerpoint/2010/main" val="1590858150"/>
+        <p14:creationId xmlns:p14="http://schemas.microsoft.com/office/powerpoint/2010/main" val="1838047273"/>
       </p:ext>
     </p:extLst>
   </p:cSld>
@@ -7468,7 +7514,7 @@
           <p:cNvPr id="7" name="">
             <a:extLst xmlns:a="http://schemas.openxmlformats.org/drawingml/2006/main">
               <a:ext uri="{FF2B5EF4-FFF2-40B4-BE49-F238E27FC236}">
-                <a16:creationId xmlns:a16="http://schemas.microsoft.com/office/drawing/2014/main" id="{4E2ED244-9A8C-445B-8F2F-9BBE5A5D40F1}"/>
+                <a16:creationId xmlns:a16="http://schemas.microsoft.com/office/drawing/2014/main" id="{31A58400-6077-4458-A223-C19DC548D1E0}"/>
               </a:ext>
             </a:extLst>
           </p:cNvPr>
@@ -7536,7 +7582,7 @@
           <p:cNvPr id="2" name="">
             <a:extLst xmlns:a="http://schemas.openxmlformats.org/drawingml/2006/main">
               <a:ext uri="{FF2B5EF4-FFF2-40B4-BE49-F238E27FC236}">
-                <a16:creationId xmlns:a16="http://schemas.microsoft.com/office/drawing/2014/main" id="{76160146-7FF6-482F-A246-ACD52E3E4367}"/>
+                <a16:creationId xmlns:a16="http://schemas.microsoft.com/office/drawing/2014/main" id="{53893052-0029-431F-AA6D-AD801411A4E2}"/>
               </a:ext>
             </a:extLst>
           </p:cNvPr>
@@ -7604,7 +7650,7 @@
           <p:cNvPr id="3" name="">
             <a:extLst xmlns:a="http://schemas.openxmlformats.org/drawingml/2006/main">
               <a:ext uri="{FF2B5EF4-FFF2-40B4-BE49-F238E27FC236}">
-                <a16:creationId xmlns:a16="http://schemas.microsoft.com/office/drawing/2014/main" id="{73EC235F-B1AB-4D70-8A59-791688A5286F}"/>
+                <a16:creationId xmlns:a16="http://schemas.microsoft.com/office/drawing/2014/main" id="{23B65E47-0AAE-4F58-900B-DFE33D611588}"/>
               </a:ext>
             </a:extLst>
           </p:cNvPr>
@@ -7672,7 +7718,7 @@
           <p:cNvPr id="4" name="">
             <a:extLst xmlns:a="http://schemas.openxmlformats.org/drawingml/2006/main">
               <a:ext uri="{FF2B5EF4-FFF2-40B4-BE49-F238E27FC236}">
-                <a16:creationId xmlns:a16="http://schemas.microsoft.com/office/drawing/2014/main" id="{8E89D3A9-BDF2-4A32-B813-74420C0BF7DD}"/>
+                <a16:creationId xmlns:a16="http://schemas.microsoft.com/office/drawing/2014/main" id="{125F801F-8C74-425E-A6E9-F9D60CFB0B4F}"/>
               </a:ext>
             </a:extLst>
           </p:cNvPr>
@@ -7740,7 +7786,7 @@
           <p:cNvPr id="5" name="">
             <a:extLst xmlns:a="http://schemas.openxmlformats.org/drawingml/2006/main">
               <a:ext uri="{FF2B5EF4-FFF2-40B4-BE49-F238E27FC236}">
-                <a16:creationId xmlns:a16="http://schemas.microsoft.com/office/drawing/2014/main" id="{B4CA466D-1CB0-423C-ACDB-7AAA6B31FA8F}"/>
+                <a16:creationId xmlns:a16="http://schemas.microsoft.com/office/drawing/2014/main" id="{9C06EE6E-C6D2-4AD1-81BB-A63AFBA9AAC9}"/>
               </a:ext>
             </a:extLst>
           </p:cNvPr>
@@ -7808,7 +7854,7 @@
           <p:cNvPr id="6" name="">
             <a:extLst xmlns:a="http://schemas.openxmlformats.org/drawingml/2006/main">
               <a:ext uri="{FF2B5EF4-FFF2-40B4-BE49-F238E27FC236}">
-                <a16:creationId xmlns:a16="http://schemas.microsoft.com/office/drawing/2014/main" id="{1BDEBD42-EC3B-4B8D-BD46-0C7D093B3B46}"/>
+                <a16:creationId xmlns:a16="http://schemas.microsoft.com/office/drawing/2014/main" id="{4FBC09C8-4A12-4886-933B-E6D41394CF6F}"/>
               </a:ext>
             </a:extLst>
           </p:cNvPr>
@@ -7874,7 +7920,7 @@
     </p:spTree>
     <p:extLst>
       <p:ext uri="{BB962C8B-B14F-4D97-AF65-F5344CB8AC3E}">
-        <p14:creationId xmlns:p14="http://schemas.microsoft.com/office/powerpoint/2010/main" val="953739485"/>
+        <p14:creationId xmlns:p14="http://schemas.microsoft.com/office/powerpoint/2010/main" val="1571989419"/>
       </p:ext>
     </p:extLst>
   </p:cSld>
@@ -7905,7 +7951,7 @@
           <p:cNvPr id="7" name="">
             <a:extLst xmlns:a="http://schemas.openxmlformats.org/drawingml/2006/main">
               <a:ext uri="{FF2B5EF4-FFF2-40B4-BE49-F238E27FC236}">
-                <a16:creationId xmlns:a16="http://schemas.microsoft.com/office/drawing/2014/main" id="{57DF043B-620D-482A-B672-FF440A9EB2B2}"/>
+                <a16:creationId xmlns:a16="http://schemas.microsoft.com/office/drawing/2014/main" id="{0F940FBC-EE8B-48A8-B52A-78EDBD370733}"/>
               </a:ext>
             </a:extLst>
           </p:cNvPr>
@@ -7963,7 +8009,7 @@
                 <a:ea typeface="Microsoft JhengHei"/>
                 <a:cs typeface="Microsoft JhengHei"/>
               </a:rPr>
-              <a:t>今天放學的一個行動</a:t>
+              <a:t>楊光梅好、安全第一</a:t>
             </a:r>
           </a:p>
         </p:txBody>
@@ -7973,7 +8019,7 @@
           <p:cNvPr id="2" name="">
             <a:extLst xmlns:a="http://schemas.openxmlformats.org/drawingml/2006/main">
               <a:ext uri="{FF2B5EF4-FFF2-40B4-BE49-F238E27FC236}">
-                <a16:creationId xmlns:a16="http://schemas.microsoft.com/office/drawing/2014/main" id="{AF3008E6-6A10-43FB-A64B-3D9D5A3EF459}"/>
+                <a16:creationId xmlns:a16="http://schemas.microsoft.com/office/drawing/2014/main" id="{03CC5765-3240-4914-AE2B-947174CA4F95}"/>
               </a:ext>
             </a:extLst>
           </p:cNvPr>
@@ -8041,7 +8087,7 @@
           <p:cNvPr id="3" name="">
             <a:extLst xmlns:a="http://schemas.openxmlformats.org/drawingml/2006/main">
               <a:ext uri="{FF2B5EF4-FFF2-40B4-BE49-F238E27FC236}">
-                <a16:creationId xmlns:a16="http://schemas.microsoft.com/office/drawing/2014/main" id="{D777A685-AAAA-4958-92FE-6FA3CB2987E9}"/>
+                <a16:creationId xmlns:a16="http://schemas.microsoft.com/office/drawing/2014/main" id="{BFB77DF0-AFF3-486B-BC33-9C87AE60FA74}"/>
               </a:ext>
             </a:extLst>
           </p:cNvPr>
@@ -8109,7 +8155,7 @@
           <p:cNvPr id="4" name="">
             <a:extLst xmlns:a="http://schemas.openxmlformats.org/drawingml/2006/main">
               <a:ext uri="{FF2B5EF4-FFF2-40B4-BE49-F238E27FC236}">
-                <a16:creationId xmlns:a16="http://schemas.microsoft.com/office/drawing/2014/main" id="{043ACF87-B2D8-4954-8C1C-BC54B3C419E6}"/>
+                <a16:creationId xmlns:a16="http://schemas.microsoft.com/office/drawing/2014/main" id="{A064A5BD-B7D5-4419-A0C9-A543D343A43D}"/>
               </a:ext>
             </a:extLst>
           </p:cNvPr>
@@ -8177,7 +8223,7 @@
           <p:cNvPr id="5" name="">
             <a:extLst xmlns:a="http://schemas.openxmlformats.org/drawingml/2006/main">
               <a:ext uri="{FF2B5EF4-FFF2-40B4-BE49-F238E27FC236}">
-                <a16:creationId xmlns:a16="http://schemas.microsoft.com/office/drawing/2014/main" id="{B033ECC7-03FA-43CA-960A-01D808CBA443}"/>
+                <a16:creationId xmlns:a16="http://schemas.microsoft.com/office/drawing/2014/main" id="{5BEA1621-D4C9-4161-A958-45CF711522EE}"/>
               </a:ext>
             </a:extLst>
           </p:cNvPr>
@@ -8245,7 +8291,7 @@
           <p:cNvPr id="6" name="">
             <a:extLst xmlns:a="http://schemas.openxmlformats.org/drawingml/2006/main">
               <a:ext uri="{FF2B5EF4-FFF2-40B4-BE49-F238E27FC236}">
-                <a16:creationId xmlns:a16="http://schemas.microsoft.com/office/drawing/2014/main" id="{EE00DB6A-E4DD-41C2-96AF-73FEA6E9CAE1}"/>
+                <a16:creationId xmlns:a16="http://schemas.microsoft.com/office/drawing/2014/main" id="{B26E640D-713A-4A60-BB96-DD0E516D1FBD}"/>
               </a:ext>
             </a:extLst>
           </p:cNvPr>
@@ -8311,7 +8357,7 @@
     </p:spTree>
     <p:extLst>
       <p:ext uri="{BB962C8B-B14F-4D97-AF65-F5344CB8AC3E}">
-        <p14:creationId xmlns:p14="http://schemas.microsoft.com/office/powerpoint/2010/main" val="237347792"/>
+        <p14:creationId xmlns:p14="http://schemas.microsoft.com/office/powerpoint/2010/main" val="1634503329"/>
       </p:ext>
     </p:extLst>
   </p:cSld>
@@ -8342,7 +8388,7 @@
           <p:cNvPr id="7" name="">
             <a:extLst xmlns:a="http://schemas.openxmlformats.org/drawingml/2006/main">
               <a:ext uri="{FF2B5EF4-FFF2-40B4-BE49-F238E27FC236}">
-                <a16:creationId xmlns:a16="http://schemas.microsoft.com/office/drawing/2014/main" id="{E3BD5375-9FC5-4127-98DD-2207D32C7280}"/>
+                <a16:creationId xmlns:a16="http://schemas.microsoft.com/office/drawing/2014/main" id="{B5E3C673-99EF-4AB1-BC70-F5AD4CF36594}"/>
               </a:ext>
             </a:extLst>
           </p:cNvPr>
@@ -8410,7 +8456,7 @@
           <p:cNvPr id="2" name="">
             <a:extLst xmlns:a="http://schemas.openxmlformats.org/drawingml/2006/main">
               <a:ext uri="{FF2B5EF4-FFF2-40B4-BE49-F238E27FC236}">
-                <a16:creationId xmlns:a16="http://schemas.microsoft.com/office/drawing/2014/main" id="{384CEF63-52AA-4286-BE67-4B2205202022}"/>
+                <a16:creationId xmlns:a16="http://schemas.microsoft.com/office/drawing/2014/main" id="{1789D658-FD43-40B0-AD6A-35C61715EACB}"/>
               </a:ext>
             </a:extLst>
           </p:cNvPr>
@@ -8478,7 +8524,7 @@
           <p:cNvPr id="3" name="">
             <a:extLst xmlns:a="http://schemas.openxmlformats.org/drawingml/2006/main">
               <a:ext uri="{FF2B5EF4-FFF2-40B4-BE49-F238E27FC236}">
-                <a16:creationId xmlns:a16="http://schemas.microsoft.com/office/drawing/2014/main" id="{7B655AE7-9545-49A1-8293-70A00E8D87B3}"/>
+                <a16:creationId xmlns:a16="http://schemas.microsoft.com/office/drawing/2014/main" id="{FF46C18E-53AE-4508-80E4-8514E7E34AF3}"/>
               </a:ext>
             </a:extLst>
           </p:cNvPr>
@@ -8546,7 +8592,7 @@
           <p:cNvPr id="4" name="">
             <a:extLst xmlns:a="http://schemas.openxmlformats.org/drawingml/2006/main">
               <a:ext uri="{FF2B5EF4-FFF2-40B4-BE49-F238E27FC236}">
-                <a16:creationId xmlns:a16="http://schemas.microsoft.com/office/drawing/2014/main" id="{C0DC39EC-1618-4C31-B769-482B3D94041D}"/>
+                <a16:creationId xmlns:a16="http://schemas.microsoft.com/office/drawing/2014/main" id="{74F5965A-A757-42D1-97C2-EB08ACACAA29}"/>
               </a:ext>
             </a:extLst>
           </p:cNvPr>
@@ -8614,7 +8660,7 @@
           <p:cNvPr id="5" name="">
             <a:extLst xmlns:a="http://schemas.openxmlformats.org/drawingml/2006/main">
               <a:ext uri="{FF2B5EF4-FFF2-40B4-BE49-F238E27FC236}">
-                <a16:creationId xmlns:a16="http://schemas.microsoft.com/office/drawing/2014/main" id="{0797D360-6875-4292-8EF3-4EBA5E5D50D1}"/>
+                <a16:creationId xmlns:a16="http://schemas.microsoft.com/office/drawing/2014/main" id="{DDAD4818-7CF4-4FCF-B3FC-57A2EFFB8C1C}"/>
               </a:ext>
             </a:extLst>
           </p:cNvPr>
@@ -8682,7 +8728,7 @@
           <p:cNvPr id="6" name="">
             <a:extLst xmlns:a="http://schemas.openxmlformats.org/drawingml/2006/main">
               <a:ext uri="{FF2B5EF4-FFF2-40B4-BE49-F238E27FC236}">
-                <a16:creationId xmlns:a16="http://schemas.microsoft.com/office/drawing/2014/main" id="{0EBD38E4-D167-431B-BBA7-CB07C830538F}"/>
+                <a16:creationId xmlns:a16="http://schemas.microsoft.com/office/drawing/2014/main" id="{BFBC296B-C39F-4B81-894A-C7D40B29F031}"/>
               </a:ext>
             </a:extLst>
           </p:cNvPr>
@@ -8748,7 +8794,7 @@
     </p:spTree>
     <p:extLst>
       <p:ext uri="{BB962C8B-B14F-4D97-AF65-F5344CB8AC3E}">
-        <p14:creationId xmlns:p14="http://schemas.microsoft.com/office/powerpoint/2010/main" val="956351519"/>
+        <p14:creationId xmlns:p14="http://schemas.microsoft.com/office/powerpoint/2010/main" val="1896806810"/>
       </p:ext>
     </p:extLst>
   </p:cSld>
@@ -8776,10 +8822,10 @@
       </p:grpSpPr>
       <p:sp>
         <p:nvSpPr>
-          <p:cNvPr id="7" name="">
+          <p:cNvPr id="6" name="">
             <a:extLst xmlns:a="http://schemas.openxmlformats.org/drawingml/2006/main">
               <a:ext uri="{FF2B5EF4-FFF2-40B4-BE49-F238E27FC236}">
-                <a16:creationId xmlns:a16="http://schemas.microsoft.com/office/drawing/2014/main" id="{FC13D4C2-0580-4FAA-AFDD-F3C7B0A6DB01}"/>
+                <a16:creationId xmlns:a16="http://schemas.microsoft.com/office/drawing/2014/main" id="{4C6E01D5-E0CD-4DE5-8446-4E79A2A49E98}"/>
               </a:ext>
             </a:extLst>
           </p:cNvPr>
@@ -8837,7 +8883,7 @@
                 <a:ea typeface="Microsoft JhengHei"/>
                 <a:cs typeface="Microsoft JhengHei"/>
               </a:rPr>
-              <a:t>今天的通學任務</a:t>
+              <a:t>課堂的兩個重點</a:t>
             </a:r>
           </a:p>
         </p:txBody>
@@ -8847,7 +8893,7 @@
           <p:cNvPr id="2" name="">
             <a:extLst xmlns:a="http://schemas.openxmlformats.org/drawingml/2006/main">
               <a:ext uri="{FF2B5EF4-FFF2-40B4-BE49-F238E27FC236}">
-                <a16:creationId xmlns:a16="http://schemas.microsoft.com/office/drawing/2014/main" id="{4962C07A-F813-4092-9BA5-394B5EEC2720}"/>
+                <a16:creationId xmlns:a16="http://schemas.microsoft.com/office/drawing/2014/main" id="{26A6AA72-175B-4F6C-938F-67BE0F0F7316}"/>
               </a:ext>
             </a:extLst>
           </p:cNvPr>
@@ -8905,7 +8951,7 @@
                 <a:ea typeface="Microsoft JhengHei"/>
                 <a:cs typeface="Microsoft JhengHei"/>
               </a:rPr>
-              <a:t>辨識新聞中的事實與推論</a:t>
+              <a:t>看懂路口風險：號誌、停讓與大型車</a:t>
             </a:r>
           </a:p>
         </p:txBody>
@@ -8915,7 +8961,7 @@
           <p:cNvPr id="3" name="">
             <a:extLst xmlns:a="http://schemas.openxmlformats.org/drawingml/2006/main">
               <a:ext uri="{FF2B5EF4-FFF2-40B4-BE49-F238E27FC236}">
-                <a16:creationId xmlns:a16="http://schemas.microsoft.com/office/drawing/2014/main" id="{51BE4034-94EE-42B1-9A90-72F276BC870A}"/>
+                <a16:creationId xmlns:a16="http://schemas.microsoft.com/office/drawing/2014/main" id="{CB798057-CFE4-4587-94C0-0B046100C851}"/>
               </a:ext>
             </a:extLst>
           </p:cNvPr>
@@ -8973,7 +9019,7 @@
                 <a:ea typeface="Microsoft JhengHei"/>
                 <a:cs typeface="Microsoft JhengHei"/>
               </a:rPr>
-              <a:t>說出風險，以及當下能做的事</a:t>
+              <a:t>做出安全通學選擇：合法騎乘與用路責任</a:t>
             </a:r>
           </a:p>
         </p:txBody>
@@ -8983,75 +9029,7 @@
           <p:cNvPr id="4" name="">
             <a:extLst xmlns:a="http://schemas.openxmlformats.org/drawingml/2006/main">
               <a:ext uri="{FF2B5EF4-FFF2-40B4-BE49-F238E27FC236}">
-                <a16:creationId xmlns:a16="http://schemas.microsoft.com/office/drawing/2014/main" id="{344DF70F-0A9D-4BB1-BA58-5CCBA91934B3}"/>
-              </a:ext>
-            </a:extLst>
-          </p:cNvPr>
-          <p:cNvSpPr>
-            <a:spLocks xmlns:a="http://schemas.openxmlformats.org/drawingml/2006/main" noGrp="1"/>
-          </p:cNvSpPr>
-          <p:nvPr/>
-        </p:nvSpPr>
-        <p:spPr>
-          <a:xfrm xmlns:a="http://schemas.openxmlformats.org/drawingml/2006/main">
-            <a:off x="714375" y="4057650"/>
-            <a:ext cx="10715625" cy="838200"/>
-          </a:xfrm>
-          <a:prstGeom xmlns:a="http://schemas.openxmlformats.org/drawingml/2006/main" prst="rect">
-            <a:avLst/>
-          </a:prstGeom>
-          <a:noFill xmlns:a="http://schemas.openxmlformats.org/drawingml/2006/main"/>
-          <a:ln xmlns:a="http://schemas.openxmlformats.org/drawingml/2006/main" w="0">
-            <a:noFill/>
-          </a:ln>
-        </p:spPr>
-        <p:txBody>
-          <a:bodyPr xmlns:a="http://schemas.openxmlformats.org/drawingml/2006/main" wrap="square" lIns="0" tIns="0" rIns="0" bIns="0" anchor="t">
-            <a:noAutofit/>
-          </a:bodyPr>
-          <a:lstStyle xmlns:a="http://schemas.openxmlformats.org/drawingml/2006/main">
-            <a:defPPr>
-              <a:defRPr sz="2475" b="0">
-                <a:solidFill>
-                  <a:srgbClr val="10283E"/>
-                </a:solidFill>
-                <a:latin typeface="Microsoft JhengHei"/>
-                <a:ea typeface="Microsoft JhengHei"/>
-                <a:cs typeface="Microsoft JhengHei"/>
-              </a:defRPr>
-            </a:defPPr>
-          </a:lstStyle>
-          <a:p xmlns:a="http://schemas.openxmlformats.org/drawingml/2006/main">
-            <a:pPr>
-              <a:defRPr sz="2475" b="0">
-                <a:solidFill>
-                  <a:srgbClr val="10283E"/>
-                </a:solidFill>
-                <a:latin typeface="Microsoft JhengHei"/>
-                <a:ea typeface="Microsoft JhengHei"/>
-                <a:cs typeface="Microsoft JhengHei"/>
-              </a:defRPr>
-            </a:pPr>
-            <a:r>
-              <a:rPr sz="2475" b="0">
-                <a:solidFill>
-                  <a:srgbClr val="10283E"/>
-                </a:solidFill>
-                <a:latin typeface="Microsoft JhengHei"/>
-                <a:ea typeface="Microsoft JhengHei"/>
-                <a:cs typeface="Microsoft JhengHei"/>
-              </a:rPr>
-              <a:t>提出一項道路環境改善</a:t>
-            </a:r>
-          </a:p>
-        </p:txBody>
-      </p:sp>
-      <p:sp>
-        <p:nvSpPr>
-          <p:cNvPr id="5" name="">
-            <a:extLst xmlns:a="http://schemas.openxmlformats.org/drawingml/2006/main">
-              <a:ext uri="{FF2B5EF4-FFF2-40B4-BE49-F238E27FC236}">
-                <a16:creationId xmlns:a16="http://schemas.microsoft.com/office/drawing/2014/main" id="{AA74B019-E16B-470A-BB53-03CD9834340F}"/>
+                <a16:creationId xmlns:a16="http://schemas.microsoft.com/office/drawing/2014/main" id="{52E73D6F-6A4B-4321-B9A3-31100F1EF20B}"/>
               </a:ext>
             </a:extLst>
           </p:cNvPr>
@@ -9116,10 +9094,10 @@
       </p:sp>
       <p:sp>
         <p:nvSpPr>
-          <p:cNvPr id="6" name="">
+          <p:cNvPr id="5" name="">
             <a:extLst xmlns:a="http://schemas.openxmlformats.org/drawingml/2006/main">
               <a:ext uri="{FF2B5EF4-FFF2-40B4-BE49-F238E27FC236}">
-                <a16:creationId xmlns:a16="http://schemas.microsoft.com/office/drawing/2014/main" id="{7AD0A9E4-2CD5-44C0-B55E-6EA4904FA19B}"/>
+                <a16:creationId xmlns:a16="http://schemas.microsoft.com/office/drawing/2014/main" id="{1DCA236E-848C-4599-8A73-7CC1F43412E4}"/>
               </a:ext>
             </a:extLst>
           </p:cNvPr>
@@ -9185,7 +9163,7 @@
     </p:spTree>
     <p:extLst>
       <p:ext uri="{BB962C8B-B14F-4D97-AF65-F5344CB8AC3E}">
-        <p14:creationId xmlns:p14="http://schemas.microsoft.com/office/powerpoint/2010/main" val="1940501934"/>
+        <p14:creationId xmlns:p14="http://schemas.microsoft.com/office/powerpoint/2010/main" val="1527240387"/>
       </p:ext>
     </p:extLst>
   </p:cSld>
@@ -9216,7 +9194,7 @@
           <p:cNvPr id="7" name="">
             <a:extLst xmlns:a="http://schemas.openxmlformats.org/drawingml/2006/main">
               <a:ext uri="{FF2B5EF4-FFF2-40B4-BE49-F238E27FC236}">
-                <a16:creationId xmlns:a16="http://schemas.microsoft.com/office/drawing/2014/main" id="{AF657120-8162-494C-992F-A33BEC40C370}"/>
+                <a16:creationId xmlns:a16="http://schemas.microsoft.com/office/drawing/2014/main" id="{9943236E-717E-402A-A4CA-489E613F713A}"/>
               </a:ext>
             </a:extLst>
           </p:cNvPr>
@@ -9284,7 +9262,7 @@
           <p:cNvPr id="2" name="">
             <a:extLst xmlns:a="http://schemas.openxmlformats.org/drawingml/2006/main">
               <a:ext uri="{FF2B5EF4-FFF2-40B4-BE49-F238E27FC236}">
-                <a16:creationId xmlns:a16="http://schemas.microsoft.com/office/drawing/2014/main" id="{4C9E302D-050C-4F59-B337-700D8FB40E7C}"/>
+                <a16:creationId xmlns:a16="http://schemas.microsoft.com/office/drawing/2014/main" id="{05269DD6-CBA5-4A1E-A95C-3DC3FFC2F450}"/>
               </a:ext>
             </a:extLst>
           </p:cNvPr>
@@ -9352,7 +9330,7 @@
           <p:cNvPr id="3" name="">
             <a:extLst xmlns:a="http://schemas.openxmlformats.org/drawingml/2006/main">
               <a:ext uri="{FF2B5EF4-FFF2-40B4-BE49-F238E27FC236}">
-                <a16:creationId xmlns:a16="http://schemas.microsoft.com/office/drawing/2014/main" id="{64F0ADFD-06B7-40B0-9372-11EFA957DDA4}"/>
+                <a16:creationId xmlns:a16="http://schemas.microsoft.com/office/drawing/2014/main" id="{FD80F801-932F-4BC1-BC08-2D8806B465CF}"/>
               </a:ext>
             </a:extLst>
           </p:cNvPr>
@@ -9420,7 +9398,7 @@
           <p:cNvPr id="4" name="">
             <a:extLst xmlns:a="http://schemas.openxmlformats.org/drawingml/2006/main">
               <a:ext uri="{FF2B5EF4-FFF2-40B4-BE49-F238E27FC236}">
-                <a16:creationId xmlns:a16="http://schemas.microsoft.com/office/drawing/2014/main" id="{3970683A-86E3-41EB-ACC0-D52BA5A17ADF}"/>
+                <a16:creationId xmlns:a16="http://schemas.microsoft.com/office/drawing/2014/main" id="{7DB92ED2-C953-409E-8F43-EA80DFD46E3A}"/>
               </a:ext>
             </a:extLst>
           </p:cNvPr>
@@ -9488,7 +9466,7 @@
           <p:cNvPr id="5" name="">
             <a:extLst xmlns:a="http://schemas.openxmlformats.org/drawingml/2006/main">
               <a:ext uri="{FF2B5EF4-FFF2-40B4-BE49-F238E27FC236}">
-                <a16:creationId xmlns:a16="http://schemas.microsoft.com/office/drawing/2014/main" id="{C60005EF-DBEF-488B-BA28-CE512E946486}"/>
+                <a16:creationId xmlns:a16="http://schemas.microsoft.com/office/drawing/2014/main" id="{44B35BD5-ADED-4B85-A8C9-194190FCEA0D}"/>
               </a:ext>
             </a:extLst>
           </p:cNvPr>
@@ -9556,7 +9534,7 @@
           <p:cNvPr id="6" name="">
             <a:extLst xmlns:a="http://schemas.openxmlformats.org/drawingml/2006/main">
               <a:ext uri="{FF2B5EF4-FFF2-40B4-BE49-F238E27FC236}">
-                <a16:creationId xmlns:a16="http://schemas.microsoft.com/office/drawing/2014/main" id="{2D3FAE19-8C3C-41AE-AC61-50CA3B0C1A81}"/>
+                <a16:creationId xmlns:a16="http://schemas.microsoft.com/office/drawing/2014/main" id="{B972BC9D-EA08-433D-9257-6582990365A7}"/>
               </a:ext>
             </a:extLst>
           </p:cNvPr>
@@ -9622,7 +9600,7 @@
     </p:spTree>
     <p:extLst>
       <p:ext uri="{BB962C8B-B14F-4D97-AF65-F5344CB8AC3E}">
-        <p14:creationId xmlns:p14="http://schemas.microsoft.com/office/powerpoint/2010/main" val="1396944328"/>
+        <p14:creationId xmlns:p14="http://schemas.microsoft.com/office/powerpoint/2010/main" val="1804803831"/>
       </p:ext>
     </p:extLst>
   </p:cSld>
@@ -9653,7 +9631,7 @@
           <p:cNvPr id="7" name="">
             <a:extLst xmlns:a="http://schemas.openxmlformats.org/drawingml/2006/main">
               <a:ext uri="{FF2B5EF4-FFF2-40B4-BE49-F238E27FC236}">
-                <a16:creationId xmlns:a16="http://schemas.microsoft.com/office/drawing/2014/main" id="{708EDC6B-A228-49EA-9D18-A7C42DF9811B}"/>
+                <a16:creationId xmlns:a16="http://schemas.microsoft.com/office/drawing/2014/main" id="{ABD45A2E-0198-45D9-860A-D2EA8FA51F84}"/>
               </a:ext>
             </a:extLst>
           </p:cNvPr>
@@ -9721,7 +9699,7 @@
           <p:cNvPr id="2" name="">
             <a:extLst xmlns:a="http://schemas.openxmlformats.org/drawingml/2006/main">
               <a:ext uri="{FF2B5EF4-FFF2-40B4-BE49-F238E27FC236}">
-                <a16:creationId xmlns:a16="http://schemas.microsoft.com/office/drawing/2014/main" id="{207BE750-06C4-49F7-9A91-0BF90B663D72}"/>
+                <a16:creationId xmlns:a16="http://schemas.microsoft.com/office/drawing/2014/main" id="{13D7A531-DB3E-4B7B-B77A-35CB317185A7}"/>
               </a:ext>
             </a:extLst>
           </p:cNvPr>
@@ -9789,7 +9767,7 @@
           <p:cNvPr id="3" name="">
             <a:extLst xmlns:a="http://schemas.openxmlformats.org/drawingml/2006/main">
               <a:ext uri="{FF2B5EF4-FFF2-40B4-BE49-F238E27FC236}">
-                <a16:creationId xmlns:a16="http://schemas.microsoft.com/office/drawing/2014/main" id="{D23C7B9E-AE6A-45B5-B79C-7045CDB59DA8}"/>
+                <a16:creationId xmlns:a16="http://schemas.microsoft.com/office/drawing/2014/main" id="{7C57AAA4-3F11-462E-B474-3AE847DA7685}"/>
               </a:ext>
             </a:extLst>
           </p:cNvPr>
@@ -9857,7 +9835,7 @@
           <p:cNvPr id="4" name="">
             <a:extLst xmlns:a="http://schemas.openxmlformats.org/drawingml/2006/main">
               <a:ext uri="{FF2B5EF4-FFF2-40B4-BE49-F238E27FC236}">
-                <a16:creationId xmlns:a16="http://schemas.microsoft.com/office/drawing/2014/main" id="{E0517BD0-4492-4DE2-A668-D52073999E98}"/>
+                <a16:creationId xmlns:a16="http://schemas.microsoft.com/office/drawing/2014/main" id="{82B88617-1598-4D78-AE25-50676758B57D}"/>
               </a:ext>
             </a:extLst>
           </p:cNvPr>
@@ -9925,7 +9903,7 @@
           <p:cNvPr id="5" name="">
             <a:extLst xmlns:a="http://schemas.openxmlformats.org/drawingml/2006/main">
               <a:ext uri="{FF2B5EF4-FFF2-40B4-BE49-F238E27FC236}">
-                <a16:creationId xmlns:a16="http://schemas.microsoft.com/office/drawing/2014/main" id="{F5185E3A-F5CA-46C7-99BB-193FF5CEC5BE}"/>
+                <a16:creationId xmlns:a16="http://schemas.microsoft.com/office/drawing/2014/main" id="{5B996445-B437-4AC9-994C-4ACA96D0C7FC}"/>
               </a:ext>
             </a:extLst>
           </p:cNvPr>
@@ -9993,7 +9971,7 @@
           <p:cNvPr id="6" name="">
             <a:extLst xmlns:a="http://schemas.openxmlformats.org/drawingml/2006/main">
               <a:ext uri="{FF2B5EF4-FFF2-40B4-BE49-F238E27FC236}">
-                <a16:creationId xmlns:a16="http://schemas.microsoft.com/office/drawing/2014/main" id="{55809CCF-C73B-48DF-9610-AF0798A08FDC}"/>
+                <a16:creationId xmlns:a16="http://schemas.microsoft.com/office/drawing/2014/main" id="{4F70E2AF-4FE4-45CA-B7DC-18CBB19B0E28}"/>
               </a:ext>
             </a:extLst>
           </p:cNvPr>
@@ -10059,7 +10037,7 @@
     </p:spTree>
     <p:extLst>
       <p:ext uri="{BB962C8B-B14F-4D97-AF65-F5344CB8AC3E}">
-        <p14:creationId xmlns:p14="http://schemas.microsoft.com/office/powerpoint/2010/main" val="1573703416"/>
+        <p14:creationId xmlns:p14="http://schemas.microsoft.com/office/powerpoint/2010/main" val="355319739"/>
       </p:ext>
     </p:extLst>
   </p:cSld>
@@ -10090,7 +10068,7 @@
           <p:cNvPr id="6" name="">
             <a:extLst xmlns:a="http://schemas.openxmlformats.org/drawingml/2006/main">
               <a:ext uri="{FF2B5EF4-FFF2-40B4-BE49-F238E27FC236}">
-                <a16:creationId xmlns:a16="http://schemas.microsoft.com/office/drawing/2014/main" id="{A0363F32-0FA8-4384-856A-165B9BAA168E}"/>
+                <a16:creationId xmlns:a16="http://schemas.microsoft.com/office/drawing/2014/main" id="{CFFC50E2-CCB8-4FA0-9D60-FC839FB61D67}"/>
               </a:ext>
             </a:extLst>
           </p:cNvPr>
@@ -10158,7 +10136,7 @@
           <p:cNvPr id="2" name="">
             <a:extLst xmlns:a="http://schemas.openxmlformats.org/drawingml/2006/main">
               <a:ext uri="{FF2B5EF4-FFF2-40B4-BE49-F238E27FC236}">
-                <a16:creationId xmlns:a16="http://schemas.microsoft.com/office/drawing/2014/main" id="{384AA7AF-C0D5-41A5-A6DC-489555B3A94F}"/>
+                <a16:creationId xmlns:a16="http://schemas.microsoft.com/office/drawing/2014/main" id="{1578C472-B8C6-433B-B983-1EE8973050D3}"/>
               </a:ext>
             </a:extLst>
           </p:cNvPr>
@@ -10226,7 +10204,7 @@
           <p:cNvPr id="3" name="">
             <a:extLst xmlns:a="http://schemas.openxmlformats.org/drawingml/2006/main">
               <a:ext uri="{FF2B5EF4-FFF2-40B4-BE49-F238E27FC236}">
-                <a16:creationId xmlns:a16="http://schemas.microsoft.com/office/drawing/2014/main" id="{5AB71E76-6536-4F17-B68D-04452F7C8D0C}"/>
+                <a16:creationId xmlns:a16="http://schemas.microsoft.com/office/drawing/2014/main" id="{48C3CAC3-2948-4B21-8176-6136301C031D}"/>
               </a:ext>
             </a:extLst>
           </p:cNvPr>
@@ -10294,7 +10272,7 @@
           <p:cNvPr id="4" name="">
             <a:extLst xmlns:a="http://schemas.openxmlformats.org/drawingml/2006/main">
               <a:ext uri="{FF2B5EF4-FFF2-40B4-BE49-F238E27FC236}">
-                <a16:creationId xmlns:a16="http://schemas.microsoft.com/office/drawing/2014/main" id="{7FF2AFA5-E633-4070-B705-F725B563B3A9}"/>
+                <a16:creationId xmlns:a16="http://schemas.microsoft.com/office/drawing/2014/main" id="{C8D681F0-3559-4616-8B52-E471FDFA037B}"/>
               </a:ext>
             </a:extLst>
           </p:cNvPr>
@@ -10351,7 +10329,7 @@
                 <a:latin typeface="Microsoft JhengHei"/>
                 <a:ea typeface="Microsoft JhengHei"/>
                 <a:cs typeface="Microsoft JhengHei"/>
-                <a:hlinkClick xmlns:r="http://schemas.openxmlformats.org/officeDocument/2006/relationships" r:id="R49f909f8139a4896"/>
+                <a:hlinkClick xmlns:r="http://schemas.openxmlformats.org/officeDocument/2006/relationships" r:id="R3d22bd401b74441b"/>
               </a:rPr>
               <a:t>公視新聞網　2026.03.11</a:t>
             </a:r>
@@ -10375,7 +10353,7 @@
                 <a:latin typeface="Microsoft JhengHei"/>
                 <a:ea typeface="Microsoft JhengHei"/>
                 <a:cs typeface="Microsoft JhengHei"/>
-                <a:hlinkClick xmlns:r="http://schemas.openxmlformats.org/officeDocument/2006/relationships" r:id="Re46752cc9dd449f6"/>
+                <a:hlinkClick xmlns:r="http://schemas.openxmlformats.org/officeDocument/2006/relationships" r:id="R8814d15a0c5f48b9"/>
               </a:rPr>
               <a:t>點選觀看新聞片段</a:t>
             </a:r>
@@ -10387,7 +10365,7 @@
           <p:cNvPr id="5" name="">
             <a:extLst xmlns:a="http://schemas.openxmlformats.org/drawingml/2006/main">
               <a:ext uri="{FF2B5EF4-FFF2-40B4-BE49-F238E27FC236}">
-                <a16:creationId xmlns:a16="http://schemas.microsoft.com/office/drawing/2014/main" id="{3E2CB970-F7DA-4577-979A-57C96D5F8C77}"/>
+                <a16:creationId xmlns:a16="http://schemas.microsoft.com/office/drawing/2014/main" id="{C929BEEC-BD09-4573-8EF8-8802F35715A5}"/>
               </a:ext>
             </a:extLst>
           </p:cNvPr>
@@ -10453,7 +10431,7 @@
     </p:spTree>
     <p:extLst>
       <p:ext uri="{BB962C8B-B14F-4D97-AF65-F5344CB8AC3E}">
-        <p14:creationId xmlns:p14="http://schemas.microsoft.com/office/powerpoint/2010/main" val="2035475117"/>
+        <p14:creationId xmlns:p14="http://schemas.microsoft.com/office/powerpoint/2010/main" val="2110889830"/>
       </p:ext>
     </p:extLst>
   </p:cSld>
@@ -10484,7 +10462,7 @@
           <p:cNvPr id="7" name="">
             <a:extLst xmlns:a="http://schemas.openxmlformats.org/drawingml/2006/main">
               <a:ext uri="{FF2B5EF4-FFF2-40B4-BE49-F238E27FC236}">
-                <a16:creationId xmlns:a16="http://schemas.microsoft.com/office/drawing/2014/main" id="{97B6DD81-48BA-499C-A7A3-8440C570018D}"/>
+                <a16:creationId xmlns:a16="http://schemas.microsoft.com/office/drawing/2014/main" id="{0B75C8E4-4578-4E27-A57F-E025B8C4BB29}"/>
               </a:ext>
             </a:extLst>
           </p:cNvPr>
@@ -10552,7 +10530,7 @@
           <p:cNvPr id="2" name="">
             <a:extLst xmlns:a="http://schemas.openxmlformats.org/drawingml/2006/main">
               <a:ext uri="{FF2B5EF4-FFF2-40B4-BE49-F238E27FC236}">
-                <a16:creationId xmlns:a16="http://schemas.microsoft.com/office/drawing/2014/main" id="{62769B08-024B-40D0-820A-89FADE376DA6}"/>
+                <a16:creationId xmlns:a16="http://schemas.microsoft.com/office/drawing/2014/main" id="{098B83D6-ABC3-43B9-94E6-DADA8F804697}"/>
               </a:ext>
             </a:extLst>
           </p:cNvPr>
@@ -10620,7 +10598,7 @@
           <p:cNvPr id="3" name="">
             <a:extLst xmlns:a="http://schemas.openxmlformats.org/drawingml/2006/main">
               <a:ext uri="{FF2B5EF4-FFF2-40B4-BE49-F238E27FC236}">
-                <a16:creationId xmlns:a16="http://schemas.microsoft.com/office/drawing/2014/main" id="{9D056715-6808-46A9-93B8-E587C641CD29}"/>
+                <a16:creationId xmlns:a16="http://schemas.microsoft.com/office/drawing/2014/main" id="{CA0959AB-61B6-40BB-8930-3C8BAB393AA8}"/>
               </a:ext>
             </a:extLst>
           </p:cNvPr>
@@ -10688,7 +10666,7 @@
           <p:cNvPr id="4" name="">
             <a:extLst xmlns:a="http://schemas.openxmlformats.org/drawingml/2006/main">
               <a:ext uri="{FF2B5EF4-FFF2-40B4-BE49-F238E27FC236}">
-                <a16:creationId xmlns:a16="http://schemas.microsoft.com/office/drawing/2014/main" id="{1CEA4AB6-D137-4BA5-B1A1-245977265F34}"/>
+                <a16:creationId xmlns:a16="http://schemas.microsoft.com/office/drawing/2014/main" id="{8ADA54DD-75D4-4301-A4BB-1ABE4EF52A4D}"/>
               </a:ext>
             </a:extLst>
           </p:cNvPr>
@@ -10756,7 +10734,7 @@
           <p:cNvPr id="5" name="">
             <a:extLst xmlns:a="http://schemas.openxmlformats.org/drawingml/2006/main">
               <a:ext uri="{FF2B5EF4-FFF2-40B4-BE49-F238E27FC236}">
-                <a16:creationId xmlns:a16="http://schemas.microsoft.com/office/drawing/2014/main" id="{D4FA46D4-407E-4F00-865F-7E0B37061F82}"/>
+                <a16:creationId xmlns:a16="http://schemas.microsoft.com/office/drawing/2014/main" id="{04D4A5C0-F90D-476C-A6FD-0603CCCF334E}"/>
               </a:ext>
             </a:extLst>
           </p:cNvPr>
@@ -10824,7 +10802,7 @@
           <p:cNvPr id="6" name="">
             <a:extLst xmlns:a="http://schemas.openxmlformats.org/drawingml/2006/main">
               <a:ext uri="{FF2B5EF4-FFF2-40B4-BE49-F238E27FC236}">
-                <a16:creationId xmlns:a16="http://schemas.microsoft.com/office/drawing/2014/main" id="{95ACB31F-790E-4FF2-A8DE-4B9ABC703B0D}"/>
+                <a16:creationId xmlns:a16="http://schemas.microsoft.com/office/drawing/2014/main" id="{4615B061-0474-418C-B248-76B92CDD9748}"/>
               </a:ext>
             </a:extLst>
           </p:cNvPr>
@@ -10890,7 +10868,7 @@
     </p:spTree>
     <p:extLst>
       <p:ext uri="{BB962C8B-B14F-4D97-AF65-F5344CB8AC3E}">
-        <p14:creationId xmlns:p14="http://schemas.microsoft.com/office/powerpoint/2010/main" val="862705711"/>
+        <p14:creationId xmlns:p14="http://schemas.microsoft.com/office/powerpoint/2010/main" val="319000311"/>
       </p:ext>
     </p:extLst>
   </p:cSld>
@@ -10921,7 +10899,7 @@
           <p:cNvPr id="7" name="">
             <a:extLst xmlns:a="http://schemas.openxmlformats.org/drawingml/2006/main">
               <a:ext uri="{FF2B5EF4-FFF2-40B4-BE49-F238E27FC236}">
-                <a16:creationId xmlns:a16="http://schemas.microsoft.com/office/drawing/2014/main" id="{AB5F1D69-2B33-4867-A288-5845643A59E3}"/>
+                <a16:creationId xmlns:a16="http://schemas.microsoft.com/office/drawing/2014/main" id="{2268B063-1D97-49C0-BEBF-B341336A4F69}"/>
               </a:ext>
             </a:extLst>
           </p:cNvPr>
@@ -10979,7 +10957,7 @@
                 <a:ea typeface="Microsoft JhengHei"/>
                 <a:cs typeface="Microsoft JhengHei"/>
               </a:rPr>
-              <a:t>行人號誌與穿越選擇</a:t>
+              <a:t>重點一　看懂路口風險</a:t>
             </a:r>
           </a:p>
         </p:txBody>
@@ -10989,7 +10967,7 @@
           <p:cNvPr id="2" name="">
             <a:extLst xmlns:a="http://schemas.openxmlformats.org/drawingml/2006/main">
               <a:ext uri="{FF2B5EF4-FFF2-40B4-BE49-F238E27FC236}">
-                <a16:creationId xmlns:a16="http://schemas.microsoft.com/office/drawing/2014/main" id="{E2105F7D-BC68-4438-8FAC-2A72FE41E62B}"/>
+                <a16:creationId xmlns:a16="http://schemas.microsoft.com/office/drawing/2014/main" id="{E94C0AB9-20A7-4550-9B17-C055A8591E1C}"/>
               </a:ext>
             </a:extLst>
           </p:cNvPr>
@@ -11057,7 +11035,7 @@
           <p:cNvPr id="3" name="">
             <a:extLst xmlns:a="http://schemas.openxmlformats.org/drawingml/2006/main">
               <a:ext uri="{FF2B5EF4-FFF2-40B4-BE49-F238E27FC236}">
-                <a16:creationId xmlns:a16="http://schemas.microsoft.com/office/drawing/2014/main" id="{F5EC7FB0-A412-4CE5-9B29-EE88AF5809DE}"/>
+                <a16:creationId xmlns:a16="http://schemas.microsoft.com/office/drawing/2014/main" id="{EBA3F0FE-ABE6-4130-91F2-035B13D2C792}"/>
               </a:ext>
             </a:extLst>
           </p:cNvPr>
@@ -11125,7 +11103,7 @@
           <p:cNvPr id="4" name="">
             <a:extLst xmlns:a="http://schemas.openxmlformats.org/drawingml/2006/main">
               <a:ext uri="{FF2B5EF4-FFF2-40B4-BE49-F238E27FC236}">
-                <a16:creationId xmlns:a16="http://schemas.microsoft.com/office/drawing/2014/main" id="{19B2DCE4-C95F-407B-A9A8-B74684747408}"/>
+                <a16:creationId xmlns:a16="http://schemas.microsoft.com/office/drawing/2014/main" id="{C2A2446A-5AA9-447B-959C-E8E1279DB28A}"/>
               </a:ext>
             </a:extLst>
           </p:cNvPr>
@@ -11193,7 +11171,7 @@
           <p:cNvPr id="5" name="">
             <a:extLst xmlns:a="http://schemas.openxmlformats.org/drawingml/2006/main">
               <a:ext uri="{FF2B5EF4-FFF2-40B4-BE49-F238E27FC236}">
-                <a16:creationId xmlns:a16="http://schemas.microsoft.com/office/drawing/2014/main" id="{C3EAFB3A-284F-4765-B5BB-52266E148B3F}"/>
+                <a16:creationId xmlns:a16="http://schemas.microsoft.com/office/drawing/2014/main" id="{B9B1E68B-88BD-466B-8BCB-6199070DEFC8}"/>
               </a:ext>
             </a:extLst>
           </p:cNvPr>
@@ -11261,7 +11239,7 @@
           <p:cNvPr id="6" name="">
             <a:extLst xmlns:a="http://schemas.openxmlformats.org/drawingml/2006/main">
               <a:ext uri="{FF2B5EF4-FFF2-40B4-BE49-F238E27FC236}">
-                <a16:creationId xmlns:a16="http://schemas.microsoft.com/office/drawing/2014/main" id="{C4E4AD50-30FB-47DC-88D5-8B84CA80DBF6}"/>
+                <a16:creationId xmlns:a16="http://schemas.microsoft.com/office/drawing/2014/main" id="{5A2100ED-917C-4E6C-841B-841AB459FAA0}"/>
               </a:ext>
             </a:extLst>
           </p:cNvPr>
@@ -11327,7 +11305,7 @@
     </p:spTree>
     <p:extLst>
       <p:ext uri="{BB962C8B-B14F-4D97-AF65-F5344CB8AC3E}">
-        <p14:creationId xmlns:p14="http://schemas.microsoft.com/office/powerpoint/2010/main" val="1079191572"/>
+        <p14:creationId xmlns:p14="http://schemas.microsoft.com/office/powerpoint/2010/main" val="1723392784"/>
       </p:ext>
     </p:extLst>
   </p:cSld>
@@ -11358,7 +11336,7 @@
           <p:cNvPr id="7" name="">
             <a:extLst xmlns:a="http://schemas.openxmlformats.org/drawingml/2006/main">
               <a:ext uri="{FF2B5EF4-FFF2-40B4-BE49-F238E27FC236}">
-                <a16:creationId xmlns:a16="http://schemas.microsoft.com/office/drawing/2014/main" id="{4B6F9038-9D2F-41DA-B7C2-964A4C75D431}"/>
+                <a16:creationId xmlns:a16="http://schemas.microsoft.com/office/drawing/2014/main" id="{37B0E9D3-343F-4C5F-B8F4-86118EF0B99E}"/>
               </a:ext>
             </a:extLst>
           </p:cNvPr>
@@ -11426,7 +11404,7 @@
           <p:cNvPr id="2" name="">
             <a:extLst xmlns:a="http://schemas.openxmlformats.org/drawingml/2006/main">
               <a:ext uri="{FF2B5EF4-FFF2-40B4-BE49-F238E27FC236}">
-                <a16:creationId xmlns:a16="http://schemas.microsoft.com/office/drawing/2014/main" id="{071986FC-2971-4F94-BB70-B586028FCCD4}"/>
+                <a16:creationId xmlns:a16="http://schemas.microsoft.com/office/drawing/2014/main" id="{CC2E86DC-5225-4D9D-8406-06C0BAD45750}"/>
               </a:ext>
             </a:extLst>
           </p:cNvPr>
@@ -11494,7 +11472,7 @@
           <p:cNvPr id="3" name="">
             <a:extLst xmlns:a="http://schemas.openxmlformats.org/drawingml/2006/main">
               <a:ext uri="{FF2B5EF4-FFF2-40B4-BE49-F238E27FC236}">
-                <a16:creationId xmlns:a16="http://schemas.microsoft.com/office/drawing/2014/main" id="{B68C511B-9265-477B-AC2D-DCE777561BC0}"/>
+                <a16:creationId xmlns:a16="http://schemas.microsoft.com/office/drawing/2014/main" id="{A2E6F544-93A5-4DE3-BD77-61A59A721AA8}"/>
               </a:ext>
             </a:extLst>
           </p:cNvPr>
@@ -11562,7 +11540,7 @@
           <p:cNvPr id="4" name="">
             <a:extLst xmlns:a="http://schemas.openxmlformats.org/drawingml/2006/main">
               <a:ext uri="{FF2B5EF4-FFF2-40B4-BE49-F238E27FC236}">
-                <a16:creationId xmlns:a16="http://schemas.microsoft.com/office/drawing/2014/main" id="{4117E565-03F7-45C7-963D-AAC9CE073574}"/>
+                <a16:creationId xmlns:a16="http://schemas.microsoft.com/office/drawing/2014/main" id="{0A3B45CA-B93F-443A-BCBB-9CCF23AC1BAD}"/>
               </a:ext>
             </a:extLst>
           </p:cNvPr>
@@ -11630,7 +11608,7 @@
           <p:cNvPr id="5" name="">
             <a:extLst xmlns:a="http://schemas.openxmlformats.org/drawingml/2006/main">
               <a:ext uri="{FF2B5EF4-FFF2-40B4-BE49-F238E27FC236}">
-                <a16:creationId xmlns:a16="http://schemas.microsoft.com/office/drawing/2014/main" id="{BD97E1CE-0679-486C-84DD-A2A72DA0A404}"/>
+                <a16:creationId xmlns:a16="http://schemas.microsoft.com/office/drawing/2014/main" id="{42F09E91-4729-4437-B484-3B92703E2F17}"/>
               </a:ext>
             </a:extLst>
           </p:cNvPr>
@@ -11698,7 +11676,7 @@
           <p:cNvPr id="6" name="">
             <a:extLst xmlns:a="http://schemas.openxmlformats.org/drawingml/2006/main">
               <a:ext uri="{FF2B5EF4-FFF2-40B4-BE49-F238E27FC236}">
-                <a16:creationId xmlns:a16="http://schemas.microsoft.com/office/drawing/2014/main" id="{E187A1A5-6F08-45BF-AE88-F0FF6FEBB9FC}"/>
+                <a16:creationId xmlns:a16="http://schemas.microsoft.com/office/drawing/2014/main" id="{590E1661-0E60-44F4-B28F-337FF64CCE27}"/>
               </a:ext>
             </a:extLst>
           </p:cNvPr>
@@ -11764,7 +11742,7 @@
     </p:spTree>
     <p:extLst>
       <p:ext uri="{BB962C8B-B14F-4D97-AF65-F5344CB8AC3E}">
-        <p14:creationId xmlns:p14="http://schemas.microsoft.com/office/powerpoint/2010/main" val="370446538"/>
+        <p14:creationId xmlns:p14="http://schemas.microsoft.com/office/powerpoint/2010/main" val="1661230124"/>
       </p:ext>
     </p:extLst>
   </p:cSld>
@@ -11795,7 +11773,7 @@
           <p:cNvPr id="7" name="">
             <a:extLst xmlns:a="http://schemas.openxmlformats.org/drawingml/2006/main">
               <a:ext uri="{FF2B5EF4-FFF2-40B4-BE49-F238E27FC236}">
-                <a16:creationId xmlns:a16="http://schemas.microsoft.com/office/drawing/2014/main" id="{760F7E43-3B52-4FD6-A10D-E9FAF5CCE908}"/>
+                <a16:creationId xmlns:a16="http://schemas.microsoft.com/office/drawing/2014/main" id="{FD09DF4F-C9D7-4E05-9BC2-826FFA9A15F8}"/>
               </a:ext>
             </a:extLst>
           </p:cNvPr>
@@ -11863,7 +11841,7 @@
           <p:cNvPr id="2" name="">
             <a:extLst xmlns:a="http://schemas.openxmlformats.org/drawingml/2006/main">
               <a:ext uri="{FF2B5EF4-FFF2-40B4-BE49-F238E27FC236}">
-                <a16:creationId xmlns:a16="http://schemas.microsoft.com/office/drawing/2014/main" id="{EBD9CB7A-CC95-4A87-9320-087A647F0B31}"/>
+                <a16:creationId xmlns:a16="http://schemas.microsoft.com/office/drawing/2014/main" id="{8AAC9849-9EFC-414E-BAD0-F1157A3B483E}"/>
               </a:ext>
             </a:extLst>
           </p:cNvPr>
@@ -11931,7 +11909,7 @@
           <p:cNvPr id="3" name="">
             <a:extLst xmlns:a="http://schemas.openxmlformats.org/drawingml/2006/main">
               <a:ext uri="{FF2B5EF4-FFF2-40B4-BE49-F238E27FC236}">
-                <a16:creationId xmlns:a16="http://schemas.microsoft.com/office/drawing/2014/main" id="{439D111C-8E49-4093-B0E1-4B155A27684C}"/>
+                <a16:creationId xmlns:a16="http://schemas.microsoft.com/office/drawing/2014/main" id="{62F5995E-954A-4714-AA9D-D152B4DAB091}"/>
               </a:ext>
             </a:extLst>
           </p:cNvPr>
@@ -11999,7 +11977,7 @@
           <p:cNvPr id="4" name="">
             <a:extLst xmlns:a="http://schemas.openxmlformats.org/drawingml/2006/main">
               <a:ext uri="{FF2B5EF4-FFF2-40B4-BE49-F238E27FC236}">
-                <a16:creationId xmlns:a16="http://schemas.microsoft.com/office/drawing/2014/main" id="{74747A68-4D93-4075-9AE3-D36A4DB69801}"/>
+                <a16:creationId xmlns:a16="http://schemas.microsoft.com/office/drawing/2014/main" id="{E4C0B79F-575F-415B-92B5-A7A9B5BA3AF6}"/>
               </a:ext>
             </a:extLst>
           </p:cNvPr>
@@ -12067,7 +12045,7 @@
           <p:cNvPr id="5" name="">
             <a:extLst xmlns:a="http://schemas.openxmlformats.org/drawingml/2006/main">
               <a:ext uri="{FF2B5EF4-FFF2-40B4-BE49-F238E27FC236}">
-                <a16:creationId xmlns:a16="http://schemas.microsoft.com/office/drawing/2014/main" id="{A8C50525-38AE-4A5D-83A8-F1B5ACD2A4F4}"/>
+                <a16:creationId xmlns:a16="http://schemas.microsoft.com/office/drawing/2014/main" id="{E350822F-0967-4296-9C16-F15576B364E6}"/>
               </a:ext>
             </a:extLst>
           </p:cNvPr>
@@ -12135,7 +12113,7 @@
           <p:cNvPr id="6" name="">
             <a:extLst xmlns:a="http://schemas.openxmlformats.org/drawingml/2006/main">
               <a:ext uri="{FF2B5EF4-FFF2-40B4-BE49-F238E27FC236}">
-                <a16:creationId xmlns:a16="http://schemas.microsoft.com/office/drawing/2014/main" id="{631BF19E-DD67-40E4-85DD-7CC60E7DF156}"/>
+                <a16:creationId xmlns:a16="http://schemas.microsoft.com/office/drawing/2014/main" id="{A4671ABB-B88E-4034-8D20-33870B32DCC2}"/>
               </a:ext>
             </a:extLst>
           </p:cNvPr>
@@ -12201,7 +12179,7 @@
     </p:spTree>
     <p:extLst>
       <p:ext uri="{BB962C8B-B14F-4D97-AF65-F5344CB8AC3E}">
-        <p14:creationId xmlns:p14="http://schemas.microsoft.com/office/powerpoint/2010/main" val="1116467497"/>
+        <p14:creationId xmlns:p14="http://schemas.microsoft.com/office/powerpoint/2010/main" val="768624208"/>
       </p:ext>
     </p:extLst>
   </p:cSld>
@@ -12232,7 +12210,7 @@
           <p:cNvPr id="7" name="">
             <a:extLst xmlns:a="http://schemas.openxmlformats.org/drawingml/2006/main">
               <a:ext uri="{FF2B5EF4-FFF2-40B4-BE49-F238E27FC236}">
-                <a16:creationId xmlns:a16="http://schemas.microsoft.com/office/drawing/2014/main" id="{39D0ACBF-F331-4439-907A-69038EE127D2}"/>
+                <a16:creationId xmlns:a16="http://schemas.microsoft.com/office/drawing/2014/main" id="{8DD2FFAF-DBC9-486F-B351-018071C34502}"/>
               </a:ext>
             </a:extLst>
           </p:cNvPr>
@@ -12290,7 +12268,7 @@
                 <a:ea typeface="Microsoft JhengHei"/>
                 <a:cs typeface="Microsoft JhengHei"/>
               </a:rPr>
-              <a:t>機車與微電車條件不同</a:t>
+              <a:t>重點二　做出安全通學選擇</a:t>
             </a:r>
           </a:p>
         </p:txBody>
@@ -12300,7 +12278,7 @@
           <p:cNvPr id="2" name="">
             <a:extLst xmlns:a="http://schemas.openxmlformats.org/drawingml/2006/main">
               <a:ext uri="{FF2B5EF4-FFF2-40B4-BE49-F238E27FC236}">
-                <a16:creationId xmlns:a16="http://schemas.microsoft.com/office/drawing/2014/main" id="{D1F34DA8-C959-44C4-ACD4-A7729B1CEF20}"/>
+                <a16:creationId xmlns:a16="http://schemas.microsoft.com/office/drawing/2014/main" id="{198AC418-B5D1-4A6D-B8C4-F0E878378E2C}"/>
               </a:ext>
             </a:extLst>
           </p:cNvPr>
@@ -12368,7 +12346,7 @@
           <p:cNvPr id="3" name="">
             <a:extLst xmlns:a="http://schemas.openxmlformats.org/drawingml/2006/main">
               <a:ext uri="{FF2B5EF4-FFF2-40B4-BE49-F238E27FC236}">
-                <a16:creationId xmlns:a16="http://schemas.microsoft.com/office/drawing/2014/main" id="{396AA22F-6C42-46DF-B713-01030B106AFF}"/>
+                <a16:creationId xmlns:a16="http://schemas.microsoft.com/office/drawing/2014/main" id="{0D16B628-D322-4326-9796-2C834908F943}"/>
               </a:ext>
             </a:extLst>
           </p:cNvPr>
@@ -12436,7 +12414,7 @@
           <p:cNvPr id="4" name="">
             <a:extLst xmlns:a="http://schemas.openxmlformats.org/drawingml/2006/main">
               <a:ext uri="{FF2B5EF4-FFF2-40B4-BE49-F238E27FC236}">
-                <a16:creationId xmlns:a16="http://schemas.microsoft.com/office/drawing/2014/main" id="{2BADC5F9-2306-4E4A-8E9C-7CECBF1B7012}"/>
+                <a16:creationId xmlns:a16="http://schemas.microsoft.com/office/drawing/2014/main" id="{E102A732-4097-4ADB-A780-1E06ED1019E3}"/>
               </a:ext>
             </a:extLst>
           </p:cNvPr>
@@ -12504,7 +12482,7 @@
           <p:cNvPr id="5" name="">
             <a:extLst xmlns:a="http://schemas.openxmlformats.org/drawingml/2006/main">
               <a:ext uri="{FF2B5EF4-FFF2-40B4-BE49-F238E27FC236}">
-                <a16:creationId xmlns:a16="http://schemas.microsoft.com/office/drawing/2014/main" id="{8322B1B6-5C09-4F0C-9B84-AC86D3221218}"/>
+                <a16:creationId xmlns:a16="http://schemas.microsoft.com/office/drawing/2014/main" id="{A3DC458E-9BB1-4A2B-80F9-44A0FF106E4D}"/>
               </a:ext>
             </a:extLst>
           </p:cNvPr>
@@ -12572,7 +12550,7 @@
           <p:cNvPr id="6" name="">
             <a:extLst xmlns:a="http://schemas.openxmlformats.org/drawingml/2006/main">
               <a:ext uri="{FF2B5EF4-FFF2-40B4-BE49-F238E27FC236}">
-                <a16:creationId xmlns:a16="http://schemas.microsoft.com/office/drawing/2014/main" id="{6BDE796E-B553-45B6-B476-F76F9DD86F11}"/>
+                <a16:creationId xmlns:a16="http://schemas.microsoft.com/office/drawing/2014/main" id="{C80C3669-B173-4FF8-9C2F-8CC2A624B2AE}"/>
               </a:ext>
             </a:extLst>
           </p:cNvPr>
@@ -12638,7 +12616,7 @@
     </p:spTree>
     <p:extLst>
       <p:ext uri="{BB962C8B-B14F-4D97-AF65-F5344CB8AC3E}">
-        <p14:creationId xmlns:p14="http://schemas.microsoft.com/office/powerpoint/2010/main" val="1453859075"/>
+        <p14:creationId xmlns:p14="http://schemas.microsoft.com/office/powerpoint/2010/main" val="1859027519"/>
       </p:ext>
     </p:extLst>
   </p:cSld>

</xml_diff>